<commit_message>
Update REDES DE COMPUTADORES.pptx
</commit_message>
<xml_diff>
--- a/Redes/REDES DE COMPUTADORES.pptx
+++ b/Redes/REDES DE COMPUTADORES.pptx
@@ -5,10 +5,10 @@
     <p:sldMasterId id="2147483672" r:id="rId1"/>
   </p:sldMasterIdLst>
   <p:notesMasterIdLst>
-    <p:notesMasterId r:id="rId24"/>
+    <p:notesMasterId r:id="rId32"/>
   </p:notesMasterIdLst>
   <p:handoutMasterIdLst>
-    <p:handoutMasterId r:id="rId25"/>
+    <p:handoutMasterId r:id="rId33"/>
   </p:handoutMasterIdLst>
   <p:sldIdLst>
     <p:sldId id="256" r:id="rId2"/>
@@ -32,7 +32,15 @@
     <p:sldId id="279" r:id="rId20"/>
     <p:sldId id="282" r:id="rId21"/>
     <p:sldId id="283" r:id="rId22"/>
-    <p:sldId id="260" r:id="rId23"/>
+    <p:sldId id="284" r:id="rId23"/>
+    <p:sldId id="286" r:id="rId24"/>
+    <p:sldId id="287" r:id="rId25"/>
+    <p:sldId id="290" r:id="rId26"/>
+    <p:sldId id="291" r:id="rId27"/>
+    <p:sldId id="288" r:id="rId28"/>
+    <p:sldId id="289" r:id="rId29"/>
+    <p:sldId id="285" r:id="rId30"/>
+    <p:sldId id="260" r:id="rId31"/>
   </p:sldIdLst>
   <p:sldSz cx="12192000" cy="6858000"/>
   <p:notesSz cx="6858000" cy="9144000"/>
@@ -238,7 +246,7 @@
             <a:pPr rtl="0"/>
             <a:fld id="{A517C7B7-34F5-4531-9889-28687F60FAC8}" type="datetime1">
               <a:rPr lang="pt-BR" smtClean="0"/>
-              <a:t>03/03/2026</a:t>
+              <a:t>06/04/2026</a:t>
             </a:fld>
             <a:endParaRPr lang="pt-BR" dirty="0"/>
           </a:p>
@@ -419,7 +427,7 @@
             <a:fld id="{40C3EC75-555C-481D-9088-738CE6DDFC83}" type="datetime1">
               <a:rPr lang="pt-BR" smtClean="0"/>
               <a:pPr/>
-              <a:t>03/03/2026</a:t>
+              <a:t>06/04/2026</a:t>
             </a:fld>
             <a:endParaRPr lang="pt-BR" dirty="0"/>
           </a:p>
@@ -842,7 +850,7 @@
             <a:pPr rtl="0"/>
             <a:fld id="{C6B3AB32-59DF-41F1-9618-EDFBF5049629}" type="slidenum">
               <a:rPr lang="pt-BR" smtClean="0"/>
-              <a:t>22</a:t>
+              <a:t>30</a:t>
             </a:fld>
             <a:endParaRPr lang="pt-BR"/>
           </a:p>
@@ -1107,7 +1115,7 @@
             <a:pPr rtl="0"/>
             <a:fld id="{2AF5B136-74F1-42D3-987D-A097EEF8F2FE}" type="datetime1">
               <a:rPr lang="pt-BR" noProof="0" smtClean="0"/>
-              <a:t>03/03/2026</a:t>
+              <a:t>06/04/2026</a:t>
             </a:fld>
             <a:endParaRPr lang="pt-BR" noProof="0"/>
           </a:p>
@@ -1372,7 +1380,7 @@
             <a:pPr rtl="0"/>
             <a:fld id="{0229B074-15EB-43FB-8347-3A734D799093}" type="datetime1">
               <a:rPr lang="pt-BR" noProof="0" smtClean="0"/>
-              <a:t>03/03/2026</a:t>
+              <a:t>06/04/2026</a:t>
             </a:fld>
             <a:endParaRPr lang="pt-BR" noProof="0"/>
           </a:p>
@@ -1610,7 +1618,7 @@
             <a:pPr rtl="0"/>
             <a:fld id="{036303E3-8DE9-4C2D-91EE-6F377AE582A8}" type="datetime1">
               <a:rPr lang="pt-BR" noProof="0" smtClean="0"/>
-              <a:t>03/03/2026</a:t>
+              <a:t>06/04/2026</a:t>
             </a:fld>
             <a:endParaRPr lang="pt-BR" noProof="0"/>
           </a:p>
@@ -1853,7 +1861,7 @@
             <a:pPr rtl="0"/>
             <a:fld id="{B04AF3F4-81C7-4F15-8991-6D0E8D06651A}" type="datetime1">
               <a:rPr lang="pt-BR" noProof="0" smtClean="0"/>
-              <a:t>03/03/2026</a:t>
+              <a:t>06/04/2026</a:t>
             </a:fld>
             <a:endParaRPr lang="pt-BR" noProof="0"/>
           </a:p>
@@ -2164,7 +2172,7 @@
             <a:pPr rtl="0"/>
             <a:fld id="{6E2946E4-8964-43BF-B1D5-4261B83248E5}" type="datetime1">
               <a:rPr lang="pt-BR" noProof="0" smtClean="0"/>
-              <a:t>03/03/2026</a:t>
+              <a:t>06/04/2026</a:t>
             </a:fld>
             <a:endParaRPr lang="pt-BR" noProof="0"/>
           </a:p>
@@ -2468,7 +2476,7 @@
             <a:pPr rtl="0"/>
             <a:fld id="{97C9F420-083C-437A-9265-7F13EB97C6A2}" type="datetime1">
               <a:rPr lang="pt-BR" noProof="0" smtClean="0"/>
-              <a:t>03/03/2026</a:t>
+              <a:t>06/04/2026</a:t>
             </a:fld>
             <a:endParaRPr lang="pt-BR" noProof="0"/>
           </a:p>
@@ -2892,7 +2900,7 @@
             <a:pPr rtl="0"/>
             <a:fld id="{BE07AF20-ED70-4B21-B799-75BB5818AB43}" type="datetime1">
               <a:rPr lang="pt-BR" noProof="0" smtClean="0"/>
-              <a:t>03/03/2026</a:t>
+              <a:t>06/04/2026</a:t>
             </a:fld>
             <a:endParaRPr lang="pt-BR" noProof="0"/>
           </a:p>
@@ -2991,7 +2999,7 @@
             <a:pPr rtl="0"/>
             <a:fld id="{0D33D876-8C34-42FC-BFF7-457557B97BB7}" type="datetime1">
               <a:rPr lang="pt-BR" noProof="0" smtClean="0"/>
-              <a:t>03/03/2026</a:t>
+              <a:t>06/04/2026</a:t>
             </a:fld>
             <a:endParaRPr lang="pt-BR" noProof="0"/>
           </a:p>
@@ -3157,7 +3165,7 @@
             <a:pPr rtl="0"/>
             <a:fld id="{4592437E-206F-4A1C-947F-806A50A40B88}" type="datetime1">
               <a:rPr lang="pt-BR" noProof="0" smtClean="0"/>
-              <a:t>03/03/2026</a:t>
+              <a:t>06/04/2026</a:t>
             </a:fld>
             <a:endParaRPr lang="pt-BR" noProof="0"/>
           </a:p>
@@ -3538,7 +3546,7 @@
             <a:pPr rtl="0"/>
             <a:fld id="{B036DDBC-F1EF-4D09-A533-5995BC167053}" type="datetime1">
               <a:rPr lang="pt-BR" noProof="0" smtClean="0"/>
-              <a:t>03/03/2026</a:t>
+              <a:t>06/04/2026</a:t>
             </a:fld>
             <a:endParaRPr lang="pt-BR" noProof="0"/>
           </a:p>
@@ -3831,7 +3839,7 @@
             <a:pPr rtl="0"/>
             <a:fld id="{DFFDDC01-A1CF-4C3A-BE96-FBC60101324D}" type="datetime1">
               <a:rPr lang="pt-BR" noProof="0" smtClean="0"/>
-              <a:t>03/03/2026</a:t>
+              <a:t>06/04/2026</a:t>
             </a:fld>
             <a:endParaRPr lang="pt-BR" noProof="0"/>
           </a:p>
@@ -4045,7 +4053,7 @@
             <a:pPr rtl="0"/>
             <a:fld id="{52266794-2CD5-4ED3-94F8-8B8DC65FDDE3}" type="datetime1">
               <a:rPr lang="pt-BR" noProof="0" smtClean="0"/>
-              <a:t>03/03/2026</a:t>
+              <a:t>06/04/2026</a:t>
             </a:fld>
             <a:endParaRPr lang="pt-BR" noProof="0"/>
           </a:p>
@@ -6843,6 +6851,1609 @@
 <file path=ppt/slides/slide22.xml><?xml version="1.0" encoding="utf-8"?>
 <p:sld xmlns:a="http://schemas.openxmlformats.org/drawingml/2006/main" xmlns:r="http://schemas.openxmlformats.org/officeDocument/2006/relationships" xmlns:p="http://schemas.openxmlformats.org/presentationml/2006/main">
   <p:cSld>
+    <p:spTree>
+      <p:nvGrpSpPr>
+        <p:cNvPr id="1" name="">
+          <a:extLst>
+            <a:ext uri="{FF2B5EF4-FFF2-40B4-BE49-F238E27FC236}">
+              <a16:creationId xmlns:a16="http://schemas.microsoft.com/office/drawing/2014/main" id="{E493CB9C-1F52-EB3A-497D-E9123CACACD8}"/>
+            </a:ext>
+          </a:extLst>
+        </p:cNvPr>
+        <p:cNvGrpSpPr/>
+        <p:nvPr/>
+      </p:nvGrpSpPr>
+      <p:grpSpPr>
+        <a:xfrm>
+          <a:off x="0" y="0"/>
+          <a:ext cx="0" cy="0"/>
+          <a:chOff x="0" y="0"/>
+          <a:chExt cx="0" cy="0"/>
+        </a:xfrm>
+      </p:grpSpPr>
+      <p:sp>
+        <p:nvSpPr>
+          <p:cNvPr id="2" name="Título 1">
+            <a:extLst>
+              <a:ext uri="{FF2B5EF4-FFF2-40B4-BE49-F238E27FC236}">
+                <a16:creationId xmlns:a16="http://schemas.microsoft.com/office/drawing/2014/main" id="{A9720919-8362-815F-5ED9-C45474B29EB3}"/>
+              </a:ext>
+            </a:extLst>
+          </p:cNvPr>
+          <p:cNvSpPr>
+            <a:spLocks noGrp="1"/>
+          </p:cNvSpPr>
+          <p:nvPr>
+            <p:ph type="title"/>
+          </p:nvPr>
+        </p:nvSpPr>
+        <p:spPr/>
+        <p:txBody>
+          <a:bodyPr/>
+          <a:lstStyle/>
+          <a:p>
+            <a:r>
+              <a:rPr lang="pt-BR" dirty="0"/>
+              <a:t>Transmissão via satélite</a:t>
+            </a:r>
+          </a:p>
+        </p:txBody>
+      </p:sp>
+      <p:pic>
+        <p:nvPicPr>
+          <p:cNvPr id="1026" name="Picture 2" descr="Artigo Como Funciona a TV por Satélite">
+            <a:extLst>
+              <a:ext uri="{FF2B5EF4-FFF2-40B4-BE49-F238E27FC236}">
+                <a16:creationId xmlns:a16="http://schemas.microsoft.com/office/drawing/2014/main" id="{0D34D90C-CDAC-8250-DEC6-A92A7932C038}"/>
+              </a:ext>
+            </a:extLst>
+          </p:cNvPr>
+          <p:cNvPicPr>
+            <a:picLocks noGrp="1" noChangeAspect="1" noChangeArrowheads="1"/>
+          </p:cNvPicPr>
+          <p:nvPr>
+            <p:ph idx="1"/>
+          </p:nvPr>
+        </p:nvPicPr>
+        <p:blipFill>
+          <a:blip r:embed="rId2">
+            <a:extLst>
+              <a:ext uri="{28A0092B-C50C-407E-A947-70E740481C1C}">
+                <a14:useLocalDpi xmlns:a14="http://schemas.microsoft.com/office/drawing/2010/main" val="0"/>
+              </a:ext>
+            </a:extLst>
+          </a:blip>
+          <a:srcRect/>
+          <a:stretch>
+            <a:fillRect/>
+          </a:stretch>
+        </p:blipFill>
+        <p:spPr bwMode="auto">
+          <a:xfrm>
+            <a:off x="3262312" y="2319178"/>
+            <a:ext cx="5195888" cy="3891901"/>
+          </a:xfrm>
+          <a:prstGeom prst="rect">
+            <a:avLst/>
+          </a:prstGeom>
+          <a:noFill/>
+          <a:extLst>
+            <a:ext uri="{909E8E84-426E-40DD-AFC4-6F175D3DCCD1}">
+              <a14:hiddenFill xmlns:a14="http://schemas.microsoft.com/office/drawing/2010/main">
+                <a:solidFill>
+                  <a:srgbClr val="FFFFFF"/>
+                </a:solidFill>
+              </a14:hiddenFill>
+            </a:ext>
+          </a:extLst>
+        </p:spPr>
+      </p:pic>
+    </p:spTree>
+    <p:extLst>
+      <p:ext uri="{BB962C8B-B14F-4D97-AF65-F5344CB8AC3E}">
+        <p14:creationId xmlns:p14="http://schemas.microsoft.com/office/powerpoint/2010/main" val="911633565"/>
+      </p:ext>
+    </p:extLst>
+  </p:cSld>
+  <p:clrMapOvr>
+    <a:masterClrMapping/>
+  </p:clrMapOvr>
+</p:sld>
+</file>
+
+<file path=ppt/slides/slide23.xml><?xml version="1.0" encoding="utf-8"?>
+<p:sld xmlns:a="http://schemas.openxmlformats.org/drawingml/2006/main" xmlns:r="http://schemas.openxmlformats.org/officeDocument/2006/relationships" xmlns:p="http://schemas.openxmlformats.org/presentationml/2006/main">
+  <p:cSld>
+    <p:spTree>
+      <p:nvGrpSpPr>
+        <p:cNvPr id="1" name=""/>
+        <p:cNvGrpSpPr/>
+        <p:nvPr/>
+      </p:nvGrpSpPr>
+      <p:grpSpPr>
+        <a:xfrm>
+          <a:off x="0" y="0"/>
+          <a:ext cx="0" cy="0"/>
+          <a:chOff x="0" y="0"/>
+          <a:chExt cx="0" cy="0"/>
+        </a:xfrm>
+      </p:grpSpPr>
+      <p:sp>
+        <p:nvSpPr>
+          <p:cNvPr id="2" name="Título 1">
+            <a:extLst>
+              <a:ext uri="{FF2B5EF4-FFF2-40B4-BE49-F238E27FC236}">
+                <a16:creationId xmlns:a16="http://schemas.microsoft.com/office/drawing/2014/main" id="{2FEC765A-EDB1-7570-9627-8F58D8F503B8}"/>
+              </a:ext>
+            </a:extLst>
+          </p:cNvPr>
+          <p:cNvSpPr>
+            <a:spLocks noGrp="1"/>
+          </p:cNvSpPr>
+          <p:nvPr>
+            <p:ph type="title"/>
+          </p:nvPr>
+        </p:nvSpPr>
+        <p:spPr/>
+        <p:txBody>
+          <a:bodyPr/>
+          <a:lstStyle/>
+          <a:p>
+            <a:r>
+              <a:rPr lang="pt-BR" dirty="0"/>
+              <a:t>CLASSIFICAÇÃO DAS REDES</a:t>
+            </a:r>
+          </a:p>
+        </p:txBody>
+      </p:sp>
+      <p:sp>
+        <p:nvSpPr>
+          <p:cNvPr id="3" name="Espaço Reservado para Conteúdo 2">
+            <a:extLst>
+              <a:ext uri="{FF2B5EF4-FFF2-40B4-BE49-F238E27FC236}">
+                <a16:creationId xmlns:a16="http://schemas.microsoft.com/office/drawing/2014/main" id="{01334B42-EA1C-E175-BF10-6999DDB79EE0}"/>
+              </a:ext>
+            </a:extLst>
+          </p:cNvPr>
+          <p:cNvSpPr>
+            <a:spLocks noGrp="1"/>
+          </p:cNvSpPr>
+          <p:nvPr>
+            <p:ph idx="1"/>
+          </p:nvPr>
+        </p:nvSpPr>
+        <p:spPr/>
+        <p:txBody>
+          <a:bodyPr>
+            <a:normAutofit fontScale="77500" lnSpcReduction="20000"/>
+          </a:bodyPr>
+          <a:lstStyle/>
+          <a:p>
+            <a:r>
+              <a:rPr lang="pt-BR" dirty="0"/>
+              <a:t>A classificação de redes em categorias pode ser feita a partir de vários critérios:</a:t>
+            </a:r>
+          </a:p>
+          <a:p>
+            <a:pPr marL="666900" lvl="1" indent="-342900">
+              <a:buFont typeface="+mj-lt"/>
+              <a:buAutoNum type="alphaLcParenR"/>
+            </a:pPr>
+            <a:r>
+              <a:rPr lang="pt-BR" dirty="0"/>
+              <a:t>dimensão ou área geográfica ocupada;</a:t>
+            </a:r>
+          </a:p>
+          <a:p>
+            <a:pPr marL="666900" lvl="1" indent="-342900">
+              <a:buFont typeface="+mj-lt"/>
+              <a:buAutoNum type="alphaLcParenR"/>
+            </a:pPr>
+            <a:r>
+              <a:rPr lang="pt-BR" dirty="0"/>
+              <a:t>capacidade de transferência de dados;</a:t>
+            </a:r>
+          </a:p>
+          <a:p>
+            <a:pPr marL="666900" lvl="1" indent="-342900">
+              <a:buFont typeface="+mj-lt"/>
+              <a:buAutoNum type="alphaLcParenR"/>
+            </a:pPr>
+            <a:r>
+              <a:rPr lang="pt-BR" dirty="0"/>
+              <a:t>topologia (forma da rede);</a:t>
+            </a:r>
+          </a:p>
+          <a:p>
+            <a:pPr marL="666900" lvl="1" indent="-342900">
+              <a:buFont typeface="+mj-lt"/>
+              <a:buAutoNum type="alphaLcParenR"/>
+            </a:pPr>
+            <a:r>
+              <a:rPr lang="pt-BR" dirty="0"/>
+              <a:t>ambiente em que se insere (rede corporativa/rede industrial);</a:t>
+            </a:r>
+          </a:p>
+          <a:p>
+            <a:pPr marL="666900" lvl="1" indent="-342900">
+              <a:buFont typeface="+mj-lt"/>
+              <a:buAutoNum type="alphaLcParenR"/>
+            </a:pPr>
+            <a:r>
+              <a:rPr lang="pt-BR" dirty="0"/>
+              <a:t>meio físico de envio de dados (redes cabeadas e redes não cabeadas);</a:t>
+            </a:r>
+          </a:p>
+          <a:p>
+            <a:pPr marL="666900" lvl="1" indent="-342900">
+              <a:buFont typeface="+mj-lt"/>
+              <a:buAutoNum type="alphaLcParenR"/>
+            </a:pPr>
+            <a:r>
+              <a:rPr lang="pt-BR" dirty="0"/>
+              <a:t>tecnologia de transmissão (redes ethernet, redes ATM). </a:t>
+            </a:r>
+            <a:br>
+              <a:rPr lang="pt-BR" dirty="0"/>
+            </a:br>
+            <a:endParaRPr lang="pt-BR" dirty="0"/>
+          </a:p>
+          <a:p>
+            <a:r>
+              <a:rPr lang="pt-BR" dirty="0"/>
+              <a:t>É convencionada a classificação das redes em locais – </a:t>
+            </a:r>
+          </a:p>
+          <a:p>
+            <a:pPr lvl="1"/>
+            <a:r>
+              <a:rPr lang="pt-BR" dirty="0" err="1"/>
+              <a:t>LANs</a:t>
+            </a:r>
+            <a:r>
+              <a:rPr lang="pt-BR" dirty="0"/>
+              <a:t> (</a:t>
+            </a:r>
+            <a:r>
+              <a:rPr lang="pt-BR" i="1" dirty="0"/>
+              <a:t>Local Area Networks</a:t>
+            </a:r>
+            <a:r>
+              <a:rPr lang="pt-BR" dirty="0"/>
+              <a:t>),</a:t>
+            </a:r>
+          </a:p>
+          <a:p>
+            <a:pPr lvl="1"/>
+            <a:r>
+              <a:rPr lang="pt-BR" dirty="0"/>
+              <a:t>Metropolitanas – </a:t>
+            </a:r>
+            <a:r>
+              <a:rPr lang="pt-BR" dirty="0" err="1"/>
+              <a:t>MANs</a:t>
+            </a:r>
+            <a:r>
+              <a:rPr lang="pt-BR" dirty="0"/>
+              <a:t> (</a:t>
+            </a:r>
+            <a:r>
+              <a:rPr lang="pt-BR" i="1" dirty="0"/>
+              <a:t>Metropolitan Area Networks</a:t>
+            </a:r>
+            <a:r>
+              <a:rPr lang="pt-BR" dirty="0"/>
+              <a:t>) e </a:t>
+            </a:r>
+          </a:p>
+          <a:p>
+            <a:pPr lvl="1"/>
+            <a:r>
+              <a:rPr lang="pt-BR" dirty="0"/>
+              <a:t>Geograficamente distribuídas – </a:t>
+            </a:r>
+            <a:r>
+              <a:rPr lang="pt-BR" dirty="0" err="1"/>
+              <a:t>WANs</a:t>
+            </a:r>
+            <a:r>
+              <a:rPr lang="pt-BR" dirty="0"/>
+              <a:t> (</a:t>
+            </a:r>
+            <a:r>
+              <a:rPr lang="pt-BR" i="1" dirty="0" err="1"/>
+              <a:t>Wide</a:t>
+            </a:r>
+            <a:r>
+              <a:rPr lang="pt-BR" i="1" dirty="0"/>
+              <a:t> Area Networks</a:t>
+            </a:r>
+            <a:r>
+              <a:rPr lang="pt-BR" dirty="0"/>
+              <a:t>). </a:t>
+            </a:r>
+            <a:br>
+              <a:rPr lang="pt-BR" dirty="0"/>
+            </a:br>
+            <a:br>
+              <a:rPr lang="pt-BR" dirty="0"/>
+            </a:br>
+            <a:endParaRPr lang="pt-BR" dirty="0"/>
+          </a:p>
+        </p:txBody>
+      </p:sp>
+    </p:spTree>
+    <p:extLst>
+      <p:ext uri="{BB962C8B-B14F-4D97-AF65-F5344CB8AC3E}">
+        <p14:creationId xmlns:p14="http://schemas.microsoft.com/office/powerpoint/2010/main" val="1769726290"/>
+      </p:ext>
+    </p:extLst>
+  </p:cSld>
+  <p:clrMapOvr>
+    <a:masterClrMapping/>
+  </p:clrMapOvr>
+</p:sld>
+</file>
+
+<file path=ppt/slides/slide24.xml><?xml version="1.0" encoding="utf-8"?>
+<p:sld xmlns:a="http://schemas.openxmlformats.org/drawingml/2006/main" xmlns:r="http://schemas.openxmlformats.org/officeDocument/2006/relationships" xmlns:p="http://schemas.openxmlformats.org/presentationml/2006/main">
+  <p:cSld>
+    <p:spTree>
+      <p:nvGrpSpPr>
+        <p:cNvPr id="1" name="">
+          <a:extLst>
+            <a:ext uri="{FF2B5EF4-FFF2-40B4-BE49-F238E27FC236}">
+              <a16:creationId xmlns:a16="http://schemas.microsoft.com/office/drawing/2014/main" id="{B659ABCC-F449-0078-9612-22BDEB52E327}"/>
+            </a:ext>
+          </a:extLst>
+        </p:cNvPr>
+        <p:cNvGrpSpPr/>
+        <p:nvPr/>
+      </p:nvGrpSpPr>
+      <p:grpSpPr>
+        <a:xfrm>
+          <a:off x="0" y="0"/>
+          <a:ext cx="0" cy="0"/>
+          <a:chOff x="0" y="0"/>
+          <a:chExt cx="0" cy="0"/>
+        </a:xfrm>
+      </p:grpSpPr>
+      <p:sp>
+        <p:nvSpPr>
+          <p:cNvPr id="2" name="Título 1">
+            <a:extLst>
+              <a:ext uri="{FF2B5EF4-FFF2-40B4-BE49-F238E27FC236}">
+                <a16:creationId xmlns:a16="http://schemas.microsoft.com/office/drawing/2014/main" id="{A4E8D7E8-FBE3-9169-3A78-11C83A9361C9}"/>
+              </a:ext>
+            </a:extLst>
+          </p:cNvPr>
+          <p:cNvSpPr>
+            <a:spLocks noGrp="1"/>
+          </p:cNvSpPr>
+          <p:nvPr>
+            <p:ph type="title"/>
+          </p:nvPr>
+        </p:nvSpPr>
+        <p:spPr/>
+        <p:txBody>
+          <a:bodyPr/>
+          <a:lstStyle/>
+          <a:p>
+            <a:r>
+              <a:rPr lang="pt-BR" dirty="0"/>
+              <a:t>CLASSIFICAÇÃO DAS REDES</a:t>
+            </a:r>
+          </a:p>
+        </p:txBody>
+      </p:sp>
+      <p:sp>
+        <p:nvSpPr>
+          <p:cNvPr id="3" name="Espaço Reservado para Conteúdo 2">
+            <a:extLst>
+              <a:ext uri="{FF2B5EF4-FFF2-40B4-BE49-F238E27FC236}">
+                <a16:creationId xmlns:a16="http://schemas.microsoft.com/office/drawing/2014/main" id="{62F0B93E-99EC-7EC8-5C9A-7E1B5356219E}"/>
+              </a:ext>
+            </a:extLst>
+          </p:cNvPr>
+          <p:cNvSpPr>
+            <a:spLocks noGrp="1"/>
+          </p:cNvSpPr>
+          <p:nvPr>
+            <p:ph idx="1"/>
+          </p:nvPr>
+        </p:nvSpPr>
+        <p:spPr>
+          <a:xfrm>
+            <a:off x="581193" y="2180496"/>
+            <a:ext cx="5033224" cy="3678303"/>
+          </a:xfrm>
+        </p:spPr>
+        <p:txBody>
+          <a:bodyPr>
+            <a:normAutofit lnSpcReduction="10000"/>
+          </a:bodyPr>
+          <a:lstStyle/>
+          <a:p>
+            <a:r>
+              <a:rPr lang="pt-BR" dirty="0" err="1"/>
+              <a:t>PANs</a:t>
+            </a:r>
+            <a:r>
+              <a:rPr lang="pt-BR" dirty="0"/>
+              <a:t> (</a:t>
+            </a:r>
+            <a:r>
+              <a:rPr lang="pt-BR" i="1" dirty="0"/>
+              <a:t>Personal Area Networks</a:t>
+            </a:r>
+            <a:r>
+              <a:rPr lang="pt-BR" dirty="0"/>
+              <a:t>),	</a:t>
+            </a:r>
+          </a:p>
+          <a:p>
+            <a:pPr lvl="1"/>
+            <a:r>
+              <a:rPr lang="pt-BR" dirty="0"/>
+              <a:t>Curtíssima extensão geográfica: cobre apenas algumas dezenas de metros</a:t>
+            </a:r>
+          </a:p>
+          <a:p>
+            <a:pPr lvl="1"/>
+            <a:r>
+              <a:rPr lang="pt-BR" dirty="0"/>
+              <a:t>Taxa de transferência relativamente baixa, em torno de 2Mbps</a:t>
+            </a:r>
+          </a:p>
+          <a:p>
+            <a:pPr lvl="1"/>
+            <a:r>
+              <a:rPr lang="pt-BR" dirty="0"/>
+              <a:t>Tecnologia relativamente nova: riscos de segurança</a:t>
+            </a:r>
+          </a:p>
+          <a:p>
+            <a:pPr lvl="1"/>
+            <a:r>
+              <a:rPr lang="pt-BR" dirty="0"/>
+              <a:t>Centraliza as operações em uma única pessoa: foco na comunicação de um único usuário e na comunicação de um dispositivo com outro</a:t>
+            </a:r>
+          </a:p>
+          <a:p>
+            <a:pPr lvl="1"/>
+            <a:r>
+              <a:rPr lang="pt-BR" dirty="0"/>
+              <a:t>Bluetooth, infravermelho </a:t>
+            </a:r>
+            <a:r>
+              <a:rPr lang="pt-BR" dirty="0" err="1"/>
+              <a:t>etc</a:t>
+            </a:r>
+            <a:br>
+              <a:rPr lang="pt-BR" dirty="0"/>
+            </a:br>
+            <a:br>
+              <a:rPr lang="pt-BR" dirty="0"/>
+            </a:br>
+            <a:br>
+              <a:rPr lang="pt-BR" dirty="0"/>
+            </a:br>
+            <a:endParaRPr lang="pt-BR" dirty="0"/>
+          </a:p>
+        </p:txBody>
+      </p:sp>
+      <p:pic>
+        <p:nvPicPr>
+          <p:cNvPr id="1026" name="Picture 2" descr="Tipos de redes: PAN, LAN, MAN, WAN – CONEXIÓN DE REDES">
+            <a:extLst>
+              <a:ext uri="{FF2B5EF4-FFF2-40B4-BE49-F238E27FC236}">
+                <a16:creationId xmlns:a16="http://schemas.microsoft.com/office/drawing/2014/main" id="{1AB1874A-6B34-BD22-361A-D25E7051AE39}"/>
+              </a:ext>
+            </a:extLst>
+          </p:cNvPr>
+          <p:cNvPicPr>
+            <a:picLocks noChangeAspect="1" noChangeArrowheads="1"/>
+          </p:cNvPicPr>
+          <p:nvPr/>
+        </p:nvPicPr>
+        <p:blipFill>
+          <a:blip r:embed="rId2">
+            <a:clrChange>
+              <a:clrFrom>
+                <a:srgbClr val="FFFFFF"/>
+              </a:clrFrom>
+              <a:clrTo>
+                <a:srgbClr val="FFFFFF">
+                  <a:alpha val="0"/>
+                </a:srgbClr>
+              </a:clrTo>
+            </a:clrChange>
+            <a:extLst>
+              <a:ext uri="{28A0092B-C50C-407E-A947-70E740481C1C}">
+                <a14:useLocalDpi xmlns:a14="http://schemas.microsoft.com/office/drawing/2010/main" val="0"/>
+              </a:ext>
+            </a:extLst>
+          </a:blip>
+          <a:srcRect/>
+          <a:stretch>
+            <a:fillRect/>
+          </a:stretch>
+        </p:blipFill>
+        <p:spPr bwMode="auto">
+          <a:xfrm>
+            <a:off x="6096000" y="2180496"/>
+            <a:ext cx="5638800" cy="3740590"/>
+          </a:xfrm>
+          <a:prstGeom prst="rect">
+            <a:avLst/>
+          </a:prstGeom>
+          <a:noFill/>
+          <a:extLst>
+            <a:ext uri="{909E8E84-426E-40DD-AFC4-6F175D3DCCD1}">
+              <a14:hiddenFill xmlns:a14="http://schemas.microsoft.com/office/drawing/2010/main">
+                <a:solidFill>
+                  <a:srgbClr val="FFFFFF"/>
+                </a:solidFill>
+              </a14:hiddenFill>
+            </a:ext>
+          </a:extLst>
+        </p:spPr>
+      </p:pic>
+    </p:spTree>
+    <p:extLst>
+      <p:ext uri="{BB962C8B-B14F-4D97-AF65-F5344CB8AC3E}">
+        <p14:creationId xmlns:p14="http://schemas.microsoft.com/office/powerpoint/2010/main" val="1716036987"/>
+      </p:ext>
+    </p:extLst>
+  </p:cSld>
+  <p:clrMapOvr>
+    <a:masterClrMapping/>
+  </p:clrMapOvr>
+</p:sld>
+</file>
+
+<file path=ppt/slides/slide25.xml><?xml version="1.0" encoding="utf-8"?>
+<p:sld xmlns:a="http://schemas.openxmlformats.org/drawingml/2006/main" xmlns:r="http://schemas.openxmlformats.org/officeDocument/2006/relationships" xmlns:p="http://schemas.openxmlformats.org/presentationml/2006/main">
+  <p:cSld>
+    <p:spTree>
+      <p:nvGrpSpPr>
+        <p:cNvPr id="1" name="">
+          <a:extLst>
+            <a:ext uri="{FF2B5EF4-FFF2-40B4-BE49-F238E27FC236}">
+              <a16:creationId xmlns:a16="http://schemas.microsoft.com/office/drawing/2014/main" id="{14B6FFA4-58EA-479C-C540-E1FEC104BF7D}"/>
+            </a:ext>
+          </a:extLst>
+        </p:cNvPr>
+        <p:cNvGrpSpPr/>
+        <p:nvPr/>
+      </p:nvGrpSpPr>
+      <p:grpSpPr>
+        <a:xfrm>
+          <a:off x="0" y="0"/>
+          <a:ext cx="0" cy="0"/>
+          <a:chOff x="0" y="0"/>
+          <a:chExt cx="0" cy="0"/>
+        </a:xfrm>
+      </p:grpSpPr>
+      <p:sp>
+        <p:nvSpPr>
+          <p:cNvPr id="2" name="Título 1">
+            <a:extLst>
+              <a:ext uri="{FF2B5EF4-FFF2-40B4-BE49-F238E27FC236}">
+                <a16:creationId xmlns:a16="http://schemas.microsoft.com/office/drawing/2014/main" id="{0EBB59A8-D7DE-36FF-33AD-50E022583124}"/>
+              </a:ext>
+            </a:extLst>
+          </p:cNvPr>
+          <p:cNvSpPr>
+            <a:spLocks noGrp="1"/>
+          </p:cNvSpPr>
+          <p:nvPr>
+            <p:ph type="title"/>
+          </p:nvPr>
+        </p:nvSpPr>
+        <p:spPr/>
+        <p:txBody>
+          <a:bodyPr/>
+          <a:lstStyle/>
+          <a:p>
+            <a:r>
+              <a:rPr lang="pt-BR" dirty="0"/>
+              <a:t>CLASSIFICAÇÃO DAS REDES</a:t>
+            </a:r>
+          </a:p>
+        </p:txBody>
+      </p:sp>
+      <p:sp>
+        <p:nvSpPr>
+          <p:cNvPr id="3" name="Espaço Reservado para Conteúdo 2">
+            <a:extLst>
+              <a:ext uri="{FF2B5EF4-FFF2-40B4-BE49-F238E27FC236}">
+                <a16:creationId xmlns:a16="http://schemas.microsoft.com/office/drawing/2014/main" id="{0DEED0AA-4AE6-C3FA-A1D8-86AAD41886C7}"/>
+              </a:ext>
+            </a:extLst>
+          </p:cNvPr>
+          <p:cNvSpPr>
+            <a:spLocks noGrp="1"/>
+          </p:cNvSpPr>
+          <p:nvPr>
+            <p:ph idx="1"/>
+          </p:nvPr>
+        </p:nvSpPr>
+        <p:spPr>
+          <a:xfrm>
+            <a:off x="581193" y="2180496"/>
+            <a:ext cx="5033224" cy="3678303"/>
+          </a:xfrm>
+        </p:spPr>
+        <p:txBody>
+          <a:bodyPr>
+            <a:normAutofit fontScale="92500" lnSpcReduction="20000"/>
+          </a:bodyPr>
+          <a:lstStyle/>
+          <a:p>
+            <a:r>
+              <a:rPr lang="pt-BR" dirty="0" err="1"/>
+              <a:t>LANs</a:t>
+            </a:r>
+            <a:r>
+              <a:rPr lang="pt-BR" dirty="0"/>
+              <a:t> (</a:t>
+            </a:r>
+            <a:r>
+              <a:rPr lang="pt-BR" i="1" dirty="0"/>
+              <a:t>Local Area Networks</a:t>
+            </a:r>
+            <a:r>
+              <a:rPr lang="pt-BR" dirty="0"/>
+              <a:t>),	</a:t>
+            </a:r>
+          </a:p>
+          <a:p>
+            <a:r>
+              <a:rPr lang="pt-BR" dirty="0"/>
+              <a:t>baixo custo e simplicidade </a:t>
+            </a:r>
+          </a:p>
+          <a:p>
+            <a:r>
+              <a:rPr lang="pt-BR" dirty="0"/>
+              <a:t>estão limitadas a apenas alguns quilômetros de extensão, como um campus universitário, um edifício, uma casa etc. </a:t>
+            </a:r>
+          </a:p>
+          <a:p>
+            <a:r>
+              <a:rPr lang="pt-BR" dirty="0"/>
+              <a:t>o acesso a esse tipo de rede é feito através de computadores pessoais ou estações de trabalho. </a:t>
+            </a:r>
+            <a:br>
+              <a:rPr lang="pt-BR" dirty="0"/>
+            </a:br>
+            <a:r>
+              <a:rPr lang="pt-BR" dirty="0"/>
+              <a:t>As duas tecnologias mais comuns são a transmissão através de cabos (coaxial, fibra óptica etc.) e a transmissão sem fio, também chamada de WLAN (</a:t>
+            </a:r>
+            <a:r>
+              <a:rPr lang="pt-BR" i="1" dirty="0"/>
+              <a:t>wireless </a:t>
+            </a:r>
+            <a:r>
+              <a:rPr lang="pt-BR" dirty="0"/>
+              <a:t>LAN) </a:t>
+            </a:r>
+          </a:p>
+          <a:p>
+            <a:r>
+              <a:rPr lang="pt-BR" dirty="0"/>
+              <a:t>A velocidade de transmissão de uma LAN varia de 10 Mbps até 10 Gbps, com baixíssimas taxas de erro ou atraso. </a:t>
+            </a:r>
+          </a:p>
+        </p:txBody>
+      </p:sp>
+      <p:pic>
+        <p:nvPicPr>
+          <p:cNvPr id="2050" name="Picture 2" descr="What is local area network (LAN) in computer – IT Release">
+            <a:extLst>
+              <a:ext uri="{FF2B5EF4-FFF2-40B4-BE49-F238E27FC236}">
+                <a16:creationId xmlns:a16="http://schemas.microsoft.com/office/drawing/2014/main" id="{2F1F8EB2-4E52-78E7-36FC-29C42498FC83}"/>
+              </a:ext>
+            </a:extLst>
+          </p:cNvPr>
+          <p:cNvPicPr>
+            <a:picLocks noChangeAspect="1" noChangeArrowheads="1"/>
+          </p:cNvPicPr>
+          <p:nvPr/>
+        </p:nvPicPr>
+        <p:blipFill>
+          <a:blip r:embed="rId2">
+            <a:extLst>
+              <a:ext uri="{28A0092B-C50C-407E-A947-70E740481C1C}">
+                <a14:useLocalDpi xmlns:a14="http://schemas.microsoft.com/office/drawing/2010/main" val="0"/>
+              </a:ext>
+            </a:extLst>
+          </a:blip>
+          <a:srcRect/>
+          <a:stretch>
+            <a:fillRect/>
+          </a:stretch>
+        </p:blipFill>
+        <p:spPr bwMode="auto">
+          <a:xfrm>
+            <a:off x="5742243" y="2014548"/>
+            <a:ext cx="5444999" cy="3960000"/>
+          </a:xfrm>
+          <a:prstGeom prst="rect">
+            <a:avLst/>
+          </a:prstGeom>
+          <a:noFill/>
+          <a:extLst>
+            <a:ext uri="{909E8E84-426E-40DD-AFC4-6F175D3DCCD1}">
+              <a14:hiddenFill xmlns:a14="http://schemas.microsoft.com/office/drawing/2010/main">
+                <a:solidFill>
+                  <a:srgbClr val="FFFFFF"/>
+                </a:solidFill>
+              </a14:hiddenFill>
+            </a:ext>
+          </a:extLst>
+        </p:spPr>
+      </p:pic>
+      <p:sp>
+        <p:nvSpPr>
+          <p:cNvPr id="4" name="CaixaDeTexto 3">
+            <a:extLst>
+              <a:ext uri="{FF2B5EF4-FFF2-40B4-BE49-F238E27FC236}">
+                <a16:creationId xmlns:a16="http://schemas.microsoft.com/office/drawing/2014/main" id="{9293006D-909D-E42C-8639-6EA586CB28A0}"/>
+              </a:ext>
+            </a:extLst>
+          </p:cNvPr>
+          <p:cNvSpPr txBox="1"/>
+          <p:nvPr/>
+        </p:nvSpPr>
+        <p:spPr>
+          <a:xfrm>
+            <a:off x="6096000" y="5894234"/>
+            <a:ext cx="4823756" cy="261610"/>
+          </a:xfrm>
+          <a:prstGeom prst="rect">
+            <a:avLst/>
+          </a:prstGeom>
+          <a:noFill/>
+        </p:spPr>
+        <p:txBody>
+          <a:bodyPr wrap="none" rtlCol="0">
+            <a:spAutoFit/>
+          </a:bodyPr>
+          <a:lstStyle/>
+          <a:p>
+            <a:r>
+              <a:rPr lang="pt-BR" sz="1100" dirty="0">
+                <a:solidFill>
+                  <a:schemeClr val="bg1">
+                    <a:lumMod val="75000"/>
+                  </a:schemeClr>
+                </a:solidFill>
+              </a:rPr>
+              <a:t>Fonte: https://itrelease.com/2021/04/what-is-local-area-network-lan-in-computer/</a:t>
+            </a:r>
+          </a:p>
+        </p:txBody>
+      </p:sp>
+    </p:spTree>
+    <p:extLst>
+      <p:ext uri="{BB962C8B-B14F-4D97-AF65-F5344CB8AC3E}">
+        <p14:creationId xmlns:p14="http://schemas.microsoft.com/office/powerpoint/2010/main" val="2093014187"/>
+      </p:ext>
+    </p:extLst>
+  </p:cSld>
+  <p:clrMapOvr>
+    <a:masterClrMapping/>
+  </p:clrMapOvr>
+</p:sld>
+</file>
+
+<file path=ppt/slides/slide26.xml><?xml version="1.0" encoding="utf-8"?>
+<p:sld xmlns:a="http://schemas.openxmlformats.org/drawingml/2006/main" xmlns:r="http://schemas.openxmlformats.org/officeDocument/2006/relationships" xmlns:p="http://schemas.openxmlformats.org/presentationml/2006/main">
+  <p:cSld>
+    <p:spTree>
+      <p:nvGrpSpPr>
+        <p:cNvPr id="1" name="">
+          <a:extLst>
+            <a:ext uri="{FF2B5EF4-FFF2-40B4-BE49-F238E27FC236}">
+              <a16:creationId xmlns:a16="http://schemas.microsoft.com/office/drawing/2014/main" id="{06F5CE68-D015-00E5-00DB-6B41EFA688F8}"/>
+            </a:ext>
+          </a:extLst>
+        </p:cNvPr>
+        <p:cNvGrpSpPr/>
+        <p:nvPr/>
+      </p:nvGrpSpPr>
+      <p:grpSpPr>
+        <a:xfrm>
+          <a:off x="0" y="0"/>
+          <a:ext cx="0" cy="0"/>
+          <a:chOff x="0" y="0"/>
+          <a:chExt cx="0" cy="0"/>
+        </a:xfrm>
+      </p:grpSpPr>
+      <p:sp>
+        <p:nvSpPr>
+          <p:cNvPr id="2" name="Título 1">
+            <a:extLst>
+              <a:ext uri="{FF2B5EF4-FFF2-40B4-BE49-F238E27FC236}">
+                <a16:creationId xmlns:a16="http://schemas.microsoft.com/office/drawing/2014/main" id="{4C1B62BB-8937-F45E-A49D-DA92788BEBA0}"/>
+              </a:ext>
+            </a:extLst>
+          </p:cNvPr>
+          <p:cNvSpPr>
+            <a:spLocks noGrp="1"/>
+          </p:cNvSpPr>
+          <p:nvPr>
+            <p:ph type="title"/>
+          </p:nvPr>
+        </p:nvSpPr>
+        <p:spPr/>
+        <p:txBody>
+          <a:bodyPr/>
+          <a:lstStyle/>
+          <a:p>
+            <a:r>
+              <a:rPr lang="pt-BR" dirty="0"/>
+              <a:t>CLASSIFICAÇÃO DAS REDES</a:t>
+            </a:r>
+          </a:p>
+        </p:txBody>
+      </p:sp>
+      <p:sp>
+        <p:nvSpPr>
+          <p:cNvPr id="3" name="Espaço Reservado para Conteúdo 2">
+            <a:extLst>
+              <a:ext uri="{FF2B5EF4-FFF2-40B4-BE49-F238E27FC236}">
+                <a16:creationId xmlns:a16="http://schemas.microsoft.com/office/drawing/2014/main" id="{FBA4E312-1DCB-B2CB-55BA-479E4C2DD5D3}"/>
+              </a:ext>
+            </a:extLst>
+          </p:cNvPr>
+          <p:cNvSpPr>
+            <a:spLocks noGrp="1"/>
+          </p:cNvSpPr>
+          <p:nvPr>
+            <p:ph idx="1"/>
+          </p:nvPr>
+        </p:nvSpPr>
+        <p:spPr>
+          <a:xfrm>
+            <a:off x="581193" y="2180496"/>
+            <a:ext cx="5033224" cy="3678303"/>
+          </a:xfrm>
+        </p:spPr>
+        <p:txBody>
+          <a:bodyPr>
+            <a:normAutofit/>
+          </a:bodyPr>
+          <a:lstStyle/>
+          <a:p>
+            <a:r>
+              <a:rPr lang="pt-BR" dirty="0" err="1"/>
+              <a:t>LANs</a:t>
+            </a:r>
+            <a:r>
+              <a:rPr lang="pt-BR" dirty="0"/>
+              <a:t> (</a:t>
+            </a:r>
+            <a:r>
+              <a:rPr lang="pt-BR" i="1" dirty="0"/>
+              <a:t>Local Area Networks</a:t>
+            </a:r>
+            <a:r>
+              <a:rPr lang="pt-BR" dirty="0"/>
+              <a:t>),	</a:t>
+            </a:r>
+          </a:p>
+          <a:p>
+            <a:r>
+              <a:rPr lang="pt-BR" dirty="0"/>
+              <a:t>Principais motivos de uso</a:t>
+            </a:r>
+          </a:p>
+          <a:p>
+            <a:pPr lvl="1"/>
+            <a:r>
+              <a:rPr lang="pt-BR" dirty="0"/>
+              <a:t>Mobilidade para o usuário: </a:t>
+            </a:r>
+          </a:p>
+          <a:p>
+            <a:pPr lvl="1"/>
+            <a:r>
+              <a:rPr lang="pt-BR" dirty="0"/>
+              <a:t>Instalação facilitada e de custo reduzido:</a:t>
+            </a:r>
+          </a:p>
+          <a:p>
+            <a:pPr lvl="1"/>
+            <a:r>
+              <a:rPr lang="pt-BR" dirty="0"/>
+              <a:t>Dispositivos compatíveis </a:t>
+            </a:r>
+          </a:p>
+        </p:txBody>
+      </p:sp>
+      <p:pic>
+        <p:nvPicPr>
+          <p:cNvPr id="2050" name="Picture 2" descr="What is local area network (LAN) in computer – IT Release">
+            <a:extLst>
+              <a:ext uri="{FF2B5EF4-FFF2-40B4-BE49-F238E27FC236}">
+                <a16:creationId xmlns:a16="http://schemas.microsoft.com/office/drawing/2014/main" id="{31AAABB4-27AA-6C65-BE34-0AC196A1D276}"/>
+              </a:ext>
+            </a:extLst>
+          </p:cNvPr>
+          <p:cNvPicPr>
+            <a:picLocks noChangeAspect="1" noChangeArrowheads="1"/>
+          </p:cNvPicPr>
+          <p:nvPr/>
+        </p:nvPicPr>
+        <p:blipFill>
+          <a:blip r:embed="rId2">
+            <a:extLst>
+              <a:ext uri="{28A0092B-C50C-407E-A947-70E740481C1C}">
+                <a14:useLocalDpi xmlns:a14="http://schemas.microsoft.com/office/drawing/2010/main" val="0"/>
+              </a:ext>
+            </a:extLst>
+          </a:blip>
+          <a:srcRect/>
+          <a:stretch>
+            <a:fillRect/>
+          </a:stretch>
+        </p:blipFill>
+        <p:spPr bwMode="auto">
+          <a:xfrm>
+            <a:off x="5742243" y="2014548"/>
+            <a:ext cx="5444999" cy="3960000"/>
+          </a:xfrm>
+          <a:prstGeom prst="rect">
+            <a:avLst/>
+          </a:prstGeom>
+          <a:noFill/>
+          <a:extLst>
+            <a:ext uri="{909E8E84-426E-40DD-AFC4-6F175D3DCCD1}">
+              <a14:hiddenFill xmlns:a14="http://schemas.microsoft.com/office/drawing/2010/main">
+                <a:solidFill>
+                  <a:srgbClr val="FFFFFF"/>
+                </a:solidFill>
+              </a14:hiddenFill>
+            </a:ext>
+          </a:extLst>
+        </p:spPr>
+      </p:pic>
+      <p:sp>
+        <p:nvSpPr>
+          <p:cNvPr id="4" name="CaixaDeTexto 3">
+            <a:extLst>
+              <a:ext uri="{FF2B5EF4-FFF2-40B4-BE49-F238E27FC236}">
+                <a16:creationId xmlns:a16="http://schemas.microsoft.com/office/drawing/2014/main" id="{047617A7-39B0-B7B1-AE66-F8AD1674B579}"/>
+              </a:ext>
+            </a:extLst>
+          </p:cNvPr>
+          <p:cNvSpPr txBox="1"/>
+          <p:nvPr/>
+        </p:nvSpPr>
+        <p:spPr>
+          <a:xfrm>
+            <a:off x="6096000" y="5894234"/>
+            <a:ext cx="4823756" cy="261610"/>
+          </a:xfrm>
+          <a:prstGeom prst="rect">
+            <a:avLst/>
+          </a:prstGeom>
+          <a:noFill/>
+        </p:spPr>
+        <p:txBody>
+          <a:bodyPr wrap="none" rtlCol="0">
+            <a:spAutoFit/>
+          </a:bodyPr>
+          <a:lstStyle/>
+          <a:p>
+            <a:r>
+              <a:rPr lang="pt-BR" sz="1100" dirty="0">
+                <a:solidFill>
+                  <a:schemeClr val="bg1">
+                    <a:lumMod val="75000"/>
+                  </a:schemeClr>
+                </a:solidFill>
+              </a:rPr>
+              <a:t>Fonte: https://itrelease.com/2021/04/what-is-local-area-network-lan-in-computer/</a:t>
+            </a:r>
+          </a:p>
+        </p:txBody>
+      </p:sp>
+    </p:spTree>
+    <p:extLst>
+      <p:ext uri="{BB962C8B-B14F-4D97-AF65-F5344CB8AC3E}">
+        <p14:creationId xmlns:p14="http://schemas.microsoft.com/office/powerpoint/2010/main" val="2316626432"/>
+      </p:ext>
+    </p:extLst>
+  </p:cSld>
+  <p:clrMapOvr>
+    <a:masterClrMapping/>
+  </p:clrMapOvr>
+</p:sld>
+</file>
+
+<file path=ppt/slides/slide27.xml><?xml version="1.0" encoding="utf-8"?>
+<p:sld xmlns:a="http://schemas.openxmlformats.org/drawingml/2006/main" xmlns:r="http://schemas.openxmlformats.org/officeDocument/2006/relationships" xmlns:p="http://schemas.openxmlformats.org/presentationml/2006/main">
+  <p:cSld>
+    <p:spTree>
+      <p:nvGrpSpPr>
+        <p:cNvPr id="1" name="">
+          <a:extLst>
+            <a:ext uri="{FF2B5EF4-FFF2-40B4-BE49-F238E27FC236}">
+              <a16:creationId xmlns:a16="http://schemas.microsoft.com/office/drawing/2014/main" id="{08B191A0-9F6B-2414-F293-28D23A97AC21}"/>
+            </a:ext>
+          </a:extLst>
+        </p:cNvPr>
+        <p:cNvGrpSpPr/>
+        <p:nvPr/>
+      </p:nvGrpSpPr>
+      <p:grpSpPr>
+        <a:xfrm>
+          <a:off x="0" y="0"/>
+          <a:ext cx="0" cy="0"/>
+          <a:chOff x="0" y="0"/>
+          <a:chExt cx="0" cy="0"/>
+        </a:xfrm>
+      </p:grpSpPr>
+      <p:sp>
+        <p:nvSpPr>
+          <p:cNvPr id="2" name="Título 1">
+            <a:extLst>
+              <a:ext uri="{FF2B5EF4-FFF2-40B4-BE49-F238E27FC236}">
+                <a16:creationId xmlns:a16="http://schemas.microsoft.com/office/drawing/2014/main" id="{3E797601-DEEA-888C-4AD3-8C8594FAEFAE}"/>
+              </a:ext>
+            </a:extLst>
+          </p:cNvPr>
+          <p:cNvSpPr>
+            <a:spLocks noGrp="1"/>
+          </p:cNvSpPr>
+          <p:nvPr>
+            <p:ph type="title"/>
+          </p:nvPr>
+        </p:nvSpPr>
+        <p:spPr/>
+        <p:txBody>
+          <a:bodyPr/>
+          <a:lstStyle/>
+          <a:p>
+            <a:r>
+              <a:rPr lang="pt-BR" dirty="0"/>
+              <a:t>CLASSIFICAÇÃO DAS REDES</a:t>
+            </a:r>
+          </a:p>
+        </p:txBody>
+      </p:sp>
+      <p:sp>
+        <p:nvSpPr>
+          <p:cNvPr id="3" name="Espaço Reservado para Conteúdo 2">
+            <a:extLst>
+              <a:ext uri="{FF2B5EF4-FFF2-40B4-BE49-F238E27FC236}">
+                <a16:creationId xmlns:a16="http://schemas.microsoft.com/office/drawing/2014/main" id="{CB2474BF-937E-A168-29E8-61C617BC723B}"/>
+              </a:ext>
+            </a:extLst>
+          </p:cNvPr>
+          <p:cNvSpPr>
+            <a:spLocks noGrp="1"/>
+          </p:cNvSpPr>
+          <p:nvPr>
+            <p:ph idx="1"/>
+          </p:nvPr>
+        </p:nvSpPr>
+        <p:spPr>
+          <a:xfrm>
+            <a:off x="581193" y="2180496"/>
+            <a:ext cx="5033224" cy="3678303"/>
+          </a:xfrm>
+        </p:spPr>
+        <p:txBody>
+          <a:bodyPr>
+            <a:normAutofit fontScale="92500" lnSpcReduction="20000"/>
+          </a:bodyPr>
+          <a:lstStyle/>
+          <a:p>
+            <a:r>
+              <a:rPr lang="pt-BR" dirty="0"/>
+              <a:t>MAN (</a:t>
+            </a:r>
+            <a:r>
+              <a:rPr lang="pt-BR" i="1" dirty="0"/>
+              <a:t>Metropolitan Area Networks</a:t>
+            </a:r>
+            <a:r>
+              <a:rPr lang="pt-BR" dirty="0"/>
+              <a:t>),	</a:t>
+            </a:r>
+          </a:p>
+          <a:p>
+            <a:r>
+              <a:rPr lang="pt-BR" dirty="0"/>
+              <a:t>Podem ser entendidas como aquelas que proveem a interligação das redes locais em uma área metropolitana de uma determinada região: rede de TV a cabo</a:t>
+            </a:r>
+          </a:p>
+          <a:p>
+            <a:r>
+              <a:rPr lang="pt-BR" dirty="0"/>
+              <a:t>São administradas por empresas que oferecem o serviço ao usuário</a:t>
+            </a:r>
+          </a:p>
+          <a:p>
+            <a:r>
+              <a:rPr lang="pt-BR" dirty="0"/>
+              <a:t>Esses tipos de rede cobrem uma extensão de centenas de quilômetros e sua velocidade de transmissão de informação varia de 155 Mbps até 10 Gbps</a:t>
+            </a:r>
+          </a:p>
+          <a:p>
+            <a:r>
+              <a:rPr lang="pt-BR" dirty="0"/>
+              <a:t>O meio utilizado para a transmissão normalmente são os cabos de fibra óptica e canais de radiofrequência. </a:t>
+            </a:r>
+          </a:p>
+        </p:txBody>
+      </p:sp>
+      <p:pic>
+        <p:nvPicPr>
+          <p:cNvPr id="6" name="Imagem 5">
+            <a:extLst>
+              <a:ext uri="{FF2B5EF4-FFF2-40B4-BE49-F238E27FC236}">
+                <a16:creationId xmlns:a16="http://schemas.microsoft.com/office/drawing/2014/main" id="{277C92C9-5894-FEF4-B437-3F0FAE7C2E2B}"/>
+              </a:ext>
+            </a:extLst>
+          </p:cNvPr>
+          <p:cNvPicPr>
+            <a:picLocks noChangeAspect="1"/>
+          </p:cNvPicPr>
+          <p:nvPr/>
+        </p:nvPicPr>
+        <p:blipFill>
+          <a:blip r:embed="rId2"/>
+          <a:stretch>
+            <a:fillRect/>
+          </a:stretch>
+        </p:blipFill>
+        <p:spPr>
+          <a:xfrm>
+            <a:off x="6241351" y="2180496"/>
+            <a:ext cx="5140092" cy="3960000"/>
+          </a:xfrm>
+          <a:prstGeom prst="rect">
+            <a:avLst/>
+          </a:prstGeom>
+        </p:spPr>
+      </p:pic>
+    </p:spTree>
+    <p:extLst>
+      <p:ext uri="{BB962C8B-B14F-4D97-AF65-F5344CB8AC3E}">
+        <p14:creationId xmlns:p14="http://schemas.microsoft.com/office/powerpoint/2010/main" val="2680548119"/>
+      </p:ext>
+    </p:extLst>
+  </p:cSld>
+  <p:clrMapOvr>
+    <a:masterClrMapping/>
+  </p:clrMapOvr>
+</p:sld>
+</file>
+
+<file path=ppt/slides/slide28.xml><?xml version="1.0" encoding="utf-8"?>
+<p:sld xmlns:a="http://schemas.openxmlformats.org/drawingml/2006/main" xmlns:r="http://schemas.openxmlformats.org/officeDocument/2006/relationships" xmlns:p="http://schemas.openxmlformats.org/presentationml/2006/main">
+  <p:cSld>
+    <p:spTree>
+      <p:nvGrpSpPr>
+        <p:cNvPr id="1" name="">
+          <a:extLst>
+            <a:ext uri="{FF2B5EF4-FFF2-40B4-BE49-F238E27FC236}">
+              <a16:creationId xmlns:a16="http://schemas.microsoft.com/office/drawing/2014/main" id="{0AF7E29F-07E8-9E8C-68EC-B4BA09095D21}"/>
+            </a:ext>
+          </a:extLst>
+        </p:cNvPr>
+        <p:cNvGrpSpPr/>
+        <p:nvPr/>
+      </p:nvGrpSpPr>
+      <p:grpSpPr>
+        <a:xfrm>
+          <a:off x="0" y="0"/>
+          <a:ext cx="0" cy="0"/>
+          <a:chOff x="0" y="0"/>
+          <a:chExt cx="0" cy="0"/>
+        </a:xfrm>
+      </p:grpSpPr>
+      <p:sp>
+        <p:nvSpPr>
+          <p:cNvPr id="2" name="Título 1">
+            <a:extLst>
+              <a:ext uri="{FF2B5EF4-FFF2-40B4-BE49-F238E27FC236}">
+                <a16:creationId xmlns:a16="http://schemas.microsoft.com/office/drawing/2014/main" id="{658E2EA8-F303-FA6D-F76A-5766A9ED266E}"/>
+              </a:ext>
+            </a:extLst>
+          </p:cNvPr>
+          <p:cNvSpPr>
+            <a:spLocks noGrp="1"/>
+          </p:cNvSpPr>
+          <p:nvPr>
+            <p:ph type="title"/>
+          </p:nvPr>
+        </p:nvSpPr>
+        <p:spPr/>
+        <p:txBody>
+          <a:bodyPr/>
+          <a:lstStyle/>
+          <a:p>
+            <a:r>
+              <a:rPr lang="pt-BR" dirty="0"/>
+              <a:t>CLASSIFICAÇÃO DAS REDES</a:t>
+            </a:r>
+          </a:p>
+        </p:txBody>
+      </p:sp>
+      <p:sp>
+        <p:nvSpPr>
+          <p:cNvPr id="3" name="Espaço Reservado para Conteúdo 2">
+            <a:extLst>
+              <a:ext uri="{FF2B5EF4-FFF2-40B4-BE49-F238E27FC236}">
+                <a16:creationId xmlns:a16="http://schemas.microsoft.com/office/drawing/2014/main" id="{0F80DB16-F3D0-E48E-68EB-03E09E80CC02}"/>
+              </a:ext>
+            </a:extLst>
+          </p:cNvPr>
+          <p:cNvSpPr>
+            <a:spLocks noGrp="1"/>
+          </p:cNvSpPr>
+          <p:nvPr>
+            <p:ph idx="1"/>
+          </p:nvPr>
+        </p:nvSpPr>
+        <p:spPr>
+          <a:xfrm>
+            <a:off x="581193" y="2180496"/>
+            <a:ext cx="5033224" cy="3678303"/>
+          </a:xfrm>
+        </p:spPr>
+        <p:txBody>
+          <a:bodyPr/>
+          <a:lstStyle/>
+          <a:p>
+            <a:r>
+              <a:rPr lang="pt-BR" dirty="0"/>
+              <a:t>WAN (</a:t>
+            </a:r>
+            <a:r>
+              <a:rPr lang="pt-BR" i="1" dirty="0" err="1"/>
+              <a:t>Wide</a:t>
+            </a:r>
+            <a:r>
+              <a:rPr lang="pt-BR" i="1" dirty="0"/>
+              <a:t> Area Networks</a:t>
+            </a:r>
+            <a:r>
+              <a:rPr lang="pt-BR" dirty="0"/>
+              <a:t>),	</a:t>
+            </a:r>
+          </a:p>
+          <a:p>
+            <a:r>
+              <a:rPr lang="pt-BR" dirty="0"/>
+              <a:t>Quando as distâncias envolvidas na interligação dos computadores são superiores a uma região metropolitana, podendo ser a dispersão geográfica tão grande quanto a distância entre continentes, a abordagem correta é a rede geograficamente distribuída (WAN</a:t>
+            </a:r>
+            <a:r>
+              <a:rPr lang="pt-BR"/>
+              <a:t>) </a:t>
+            </a:r>
+            <a:endParaRPr lang="pt-BR" dirty="0"/>
+          </a:p>
+        </p:txBody>
+      </p:sp>
+      <p:pic>
+        <p:nvPicPr>
+          <p:cNvPr id="4098" name="Picture 2" descr="Wide Area Network Images – Browse 45,529 Stock Photos, Vectors, and Video |  Adobe Stock">
+            <a:extLst>
+              <a:ext uri="{FF2B5EF4-FFF2-40B4-BE49-F238E27FC236}">
+                <a16:creationId xmlns:a16="http://schemas.microsoft.com/office/drawing/2014/main" id="{8FBDE4FD-C3A4-3AE8-D589-14B41108B690}"/>
+              </a:ext>
+            </a:extLst>
+          </p:cNvPr>
+          <p:cNvPicPr>
+            <a:picLocks noChangeAspect="1" noChangeArrowheads="1"/>
+          </p:cNvPicPr>
+          <p:nvPr/>
+        </p:nvPicPr>
+        <p:blipFill>
+          <a:blip r:embed="rId2">
+            <a:extLst>
+              <a:ext uri="{28A0092B-C50C-407E-A947-70E740481C1C}">
+                <a14:useLocalDpi xmlns:a14="http://schemas.microsoft.com/office/drawing/2010/main" val="0"/>
+              </a:ext>
+            </a:extLst>
+          </a:blip>
+          <a:srcRect/>
+          <a:stretch>
+            <a:fillRect/>
+          </a:stretch>
+        </p:blipFill>
+        <p:spPr bwMode="auto">
+          <a:xfrm>
+            <a:off x="5791772" y="2305147"/>
+            <a:ext cx="5381625" cy="3429000"/>
+          </a:xfrm>
+          <a:prstGeom prst="rect">
+            <a:avLst/>
+          </a:prstGeom>
+          <a:noFill/>
+          <a:extLst>
+            <a:ext uri="{909E8E84-426E-40DD-AFC4-6F175D3DCCD1}">
+              <a14:hiddenFill xmlns:a14="http://schemas.microsoft.com/office/drawing/2010/main">
+                <a:solidFill>
+                  <a:srgbClr val="FFFFFF"/>
+                </a:solidFill>
+              </a14:hiddenFill>
+            </a:ext>
+          </a:extLst>
+        </p:spPr>
+      </p:pic>
+    </p:spTree>
+    <p:extLst>
+      <p:ext uri="{BB962C8B-B14F-4D97-AF65-F5344CB8AC3E}">
+        <p14:creationId xmlns:p14="http://schemas.microsoft.com/office/powerpoint/2010/main" val="1134796677"/>
+      </p:ext>
+    </p:extLst>
+  </p:cSld>
+  <p:clrMapOvr>
+    <a:masterClrMapping/>
+  </p:clrMapOvr>
+</p:sld>
+</file>
+
+<file path=ppt/slides/slide29.xml><?xml version="1.0" encoding="utf-8"?>
+<p:sld xmlns:a="http://schemas.openxmlformats.org/drawingml/2006/main" xmlns:r="http://schemas.openxmlformats.org/officeDocument/2006/relationships" xmlns:p="http://schemas.openxmlformats.org/presentationml/2006/main">
+  <p:cSld>
+    <p:spTree>
+      <p:nvGrpSpPr>
+        <p:cNvPr id="1" name=""/>
+        <p:cNvGrpSpPr/>
+        <p:nvPr/>
+      </p:nvGrpSpPr>
+      <p:grpSpPr>
+        <a:xfrm>
+          <a:off x="0" y="0"/>
+          <a:ext cx="0" cy="0"/>
+          <a:chOff x="0" y="0"/>
+          <a:chExt cx="0" cy="0"/>
+        </a:xfrm>
+      </p:grpSpPr>
+      <p:sp>
+        <p:nvSpPr>
+          <p:cNvPr id="2" name="Título 1">
+            <a:extLst>
+              <a:ext uri="{FF2B5EF4-FFF2-40B4-BE49-F238E27FC236}">
+                <a16:creationId xmlns:a16="http://schemas.microsoft.com/office/drawing/2014/main" id="{74AB2FC4-B32E-AB2F-F56E-49D6EC5ED820}"/>
+              </a:ext>
+            </a:extLst>
+          </p:cNvPr>
+          <p:cNvSpPr>
+            <a:spLocks noGrp="1"/>
+          </p:cNvSpPr>
+          <p:nvPr>
+            <p:ph type="title"/>
+          </p:nvPr>
+        </p:nvSpPr>
+        <p:spPr/>
+        <p:txBody>
+          <a:bodyPr/>
+          <a:lstStyle/>
+          <a:p>
+            <a:r>
+              <a:rPr lang="pt-BR" dirty="0"/>
+              <a:t>Topologia de redes</a:t>
+            </a:r>
+          </a:p>
+        </p:txBody>
+      </p:sp>
+      <p:sp>
+        <p:nvSpPr>
+          <p:cNvPr id="3" name="Espaço Reservado para Conteúdo 2">
+            <a:extLst>
+              <a:ext uri="{FF2B5EF4-FFF2-40B4-BE49-F238E27FC236}">
+                <a16:creationId xmlns:a16="http://schemas.microsoft.com/office/drawing/2014/main" id="{2F6B353C-1A5B-7BB5-0A90-A4B31FB88685}"/>
+              </a:ext>
+            </a:extLst>
+          </p:cNvPr>
+          <p:cNvSpPr>
+            <a:spLocks noGrp="1"/>
+          </p:cNvSpPr>
+          <p:nvPr>
+            <p:ph idx="1"/>
+          </p:nvPr>
+        </p:nvSpPr>
+        <p:spPr/>
+        <p:txBody>
+          <a:bodyPr>
+            <a:normAutofit/>
+          </a:bodyPr>
+          <a:lstStyle/>
+          <a:p>
+            <a:r>
+              <a:rPr lang="pt-BR" dirty="0"/>
+              <a:t>A topologia </a:t>
+            </a:r>
+            <a:r>
+              <a:rPr lang="pt-BR" u="sng" dirty="0"/>
+              <a:t>refere-se à disposição dos componentes físicos e ao meio de conexão dos dispositivos na rede, ou seja, como estes estão conectados</a:t>
+            </a:r>
+            <a:r>
+              <a:rPr lang="pt-BR" dirty="0"/>
+              <a:t>.</a:t>
+            </a:r>
+          </a:p>
+          <a:p>
+            <a:r>
+              <a:rPr lang="pt-BR" dirty="0"/>
+              <a:t>A topologia de uma rede </a:t>
+            </a:r>
+            <a:r>
+              <a:rPr lang="pt-BR" u="sng" dirty="0"/>
+              <a:t>depende do projeto das operações, da confiabilidade e do seu custo operacional</a:t>
+            </a:r>
+            <a:r>
+              <a:rPr lang="pt-BR" dirty="0"/>
+              <a:t>.</a:t>
+            </a:r>
+          </a:p>
+          <a:p>
+            <a:r>
+              <a:rPr lang="pt-BR" dirty="0"/>
+              <a:t>Ao se projetar uma rede, muitos fatores devem ser considerados, mas </a:t>
+            </a:r>
+            <a:r>
+              <a:rPr lang="pt-BR" u="sng" dirty="0"/>
+              <a:t>a topologia a ser empregada é de total importância para o bom desempenho e retorno do investimento de uma rede</a:t>
+            </a:r>
+            <a:r>
+              <a:rPr lang="pt-BR" dirty="0"/>
+              <a:t>.</a:t>
+            </a:r>
+          </a:p>
+          <a:p>
+            <a:r>
+              <a:rPr lang="pt-BR" u="sng" dirty="0"/>
+              <a:t>Cada topologia possui suas características, com diferentes implicações quanto ao desenvolvimento, operação e manutenção da rede</a:t>
+            </a:r>
+            <a:r>
+              <a:rPr lang="pt-BR" dirty="0"/>
+              <a:t>, além disso, cada topologia apresenta duas formas, </a:t>
+            </a:r>
+            <a:r>
+              <a:rPr lang="pt-BR" u="sng" dirty="0"/>
+              <a:t>a forma física e a lógica</a:t>
+            </a:r>
+            <a:r>
+              <a:rPr lang="pt-BR" dirty="0"/>
+              <a:t>. A topologia em </a:t>
+            </a:r>
+            <a:r>
+              <a:rPr lang="pt-BR" u="sng" dirty="0"/>
+              <a:t>sua forma física identifica como os nós estão interconectados uns nos outros</a:t>
+            </a:r>
+            <a:r>
+              <a:rPr lang="pt-BR" dirty="0"/>
+              <a:t>. </a:t>
+            </a:r>
+            <a:br>
+              <a:rPr lang="pt-BR" dirty="0"/>
+            </a:br>
+            <a:endParaRPr lang="pt-BR" dirty="0"/>
+          </a:p>
+        </p:txBody>
+      </p:sp>
+    </p:spTree>
+    <p:extLst>
+      <p:ext uri="{BB962C8B-B14F-4D97-AF65-F5344CB8AC3E}">
+        <p14:creationId xmlns:p14="http://schemas.microsoft.com/office/powerpoint/2010/main" val="2448624542"/>
+      </p:ext>
+    </p:extLst>
+  </p:cSld>
+  <p:clrMapOvr>
+    <a:masterClrMapping/>
+  </p:clrMapOvr>
+</p:sld>
+</file>
+
+<file path=ppt/slides/slide3.xml><?xml version="1.0" encoding="utf-8"?>
+<p:sld xmlns:a="http://schemas.openxmlformats.org/drawingml/2006/main" xmlns:r="http://schemas.openxmlformats.org/officeDocument/2006/relationships" xmlns:p="http://schemas.openxmlformats.org/presentationml/2006/main">
+  <p:cSld>
+    <p:spTree>
+      <p:nvGrpSpPr>
+        <p:cNvPr id="1" name=""/>
+        <p:cNvGrpSpPr/>
+        <p:nvPr/>
+      </p:nvGrpSpPr>
+      <p:grpSpPr>
+        <a:xfrm>
+          <a:off x="0" y="0"/>
+          <a:ext cx="0" cy="0"/>
+          <a:chOff x="0" y="0"/>
+          <a:chExt cx="0" cy="0"/>
+        </a:xfrm>
+      </p:grpSpPr>
+      <p:sp>
+        <p:nvSpPr>
+          <p:cNvPr id="2" name="Título 1">
+            <a:extLst>
+              <a:ext uri="{FF2B5EF4-FFF2-40B4-BE49-F238E27FC236}">
+                <a16:creationId xmlns:a16="http://schemas.microsoft.com/office/drawing/2014/main" id="{EE0620E7-5BAC-CDE7-C13E-FF14FABE3865}"/>
+              </a:ext>
+            </a:extLst>
+          </p:cNvPr>
+          <p:cNvSpPr>
+            <a:spLocks noGrp="1"/>
+          </p:cNvSpPr>
+          <p:nvPr>
+            <p:ph type="title"/>
+          </p:nvPr>
+        </p:nvSpPr>
+        <p:spPr/>
+        <p:txBody>
+          <a:bodyPr/>
+          <a:lstStyle/>
+          <a:p>
+            <a:r>
+              <a:rPr lang="pt-BR" dirty="0"/>
+              <a:t>O QUE SÃO REDES</a:t>
+            </a:r>
+          </a:p>
+        </p:txBody>
+      </p:sp>
+      <p:sp>
+        <p:nvSpPr>
+          <p:cNvPr id="3" name="Espaço Reservado para Conteúdo 2">
+            <a:extLst>
+              <a:ext uri="{FF2B5EF4-FFF2-40B4-BE49-F238E27FC236}">
+                <a16:creationId xmlns:a16="http://schemas.microsoft.com/office/drawing/2014/main" id="{77E062BC-B745-85DD-C631-2AFFE9455B0D}"/>
+              </a:ext>
+            </a:extLst>
+          </p:cNvPr>
+          <p:cNvSpPr>
+            <a:spLocks noGrp="1"/>
+          </p:cNvSpPr>
+          <p:nvPr>
+            <p:ph idx="1"/>
+          </p:nvPr>
+        </p:nvSpPr>
+        <p:spPr>
+          <a:xfrm>
+            <a:off x="1395663" y="2180496"/>
+            <a:ext cx="10215144" cy="3678303"/>
+          </a:xfrm>
+        </p:spPr>
+        <p:txBody>
+          <a:bodyPr>
+            <a:normAutofit/>
+          </a:bodyPr>
+          <a:lstStyle/>
+          <a:p>
+            <a:r>
+              <a:rPr lang="pt-BR" sz="2400" dirty="0"/>
+              <a:t>Uma rede de computadores é a forma de conectarmos equipamentos a fim de que possamos estabelecer uma comunicação entre os mesmos fazendo com que eles troquem dados, informações e serviços. </a:t>
+            </a:r>
+          </a:p>
+        </p:txBody>
+      </p:sp>
+    </p:spTree>
+    <p:extLst>
+      <p:ext uri="{BB962C8B-B14F-4D97-AF65-F5344CB8AC3E}">
+        <p14:creationId xmlns:p14="http://schemas.microsoft.com/office/powerpoint/2010/main" val="2869987137"/>
+      </p:ext>
+    </p:extLst>
+  </p:cSld>
+  <p:clrMapOvr>
+    <a:masterClrMapping/>
+  </p:clrMapOvr>
+</p:sld>
+</file>
+
+<file path=ppt/slides/slide30.xml><?xml version="1.0" encoding="utf-8"?>
+<p:sld xmlns:a="http://schemas.openxmlformats.org/drawingml/2006/main" xmlns:r="http://schemas.openxmlformats.org/officeDocument/2006/relationships" xmlns:p="http://schemas.openxmlformats.org/presentationml/2006/main">
+  <p:cSld>
     <p:bg>
       <p:bgPr>
         <a:solidFill>
@@ -7271,99 +8882,6 @@
     <p:extLst>
       <p:ext uri="{BB962C8B-B14F-4D97-AF65-F5344CB8AC3E}">
         <p14:creationId xmlns:p14="http://schemas.microsoft.com/office/powerpoint/2010/main" val="3501347425"/>
-      </p:ext>
-    </p:extLst>
-  </p:cSld>
-  <p:clrMapOvr>
-    <a:masterClrMapping/>
-  </p:clrMapOvr>
-</p:sld>
-</file>
-
-<file path=ppt/slides/slide3.xml><?xml version="1.0" encoding="utf-8"?>
-<p:sld xmlns:a="http://schemas.openxmlformats.org/drawingml/2006/main" xmlns:r="http://schemas.openxmlformats.org/officeDocument/2006/relationships" xmlns:p="http://schemas.openxmlformats.org/presentationml/2006/main">
-  <p:cSld>
-    <p:spTree>
-      <p:nvGrpSpPr>
-        <p:cNvPr id="1" name=""/>
-        <p:cNvGrpSpPr/>
-        <p:nvPr/>
-      </p:nvGrpSpPr>
-      <p:grpSpPr>
-        <a:xfrm>
-          <a:off x="0" y="0"/>
-          <a:ext cx="0" cy="0"/>
-          <a:chOff x="0" y="0"/>
-          <a:chExt cx="0" cy="0"/>
-        </a:xfrm>
-      </p:grpSpPr>
-      <p:sp>
-        <p:nvSpPr>
-          <p:cNvPr id="2" name="Título 1">
-            <a:extLst>
-              <a:ext uri="{FF2B5EF4-FFF2-40B4-BE49-F238E27FC236}">
-                <a16:creationId xmlns:a16="http://schemas.microsoft.com/office/drawing/2014/main" id="{EE0620E7-5BAC-CDE7-C13E-FF14FABE3865}"/>
-              </a:ext>
-            </a:extLst>
-          </p:cNvPr>
-          <p:cNvSpPr>
-            <a:spLocks noGrp="1"/>
-          </p:cNvSpPr>
-          <p:nvPr>
-            <p:ph type="title"/>
-          </p:nvPr>
-        </p:nvSpPr>
-        <p:spPr/>
-        <p:txBody>
-          <a:bodyPr/>
-          <a:lstStyle/>
-          <a:p>
-            <a:r>
-              <a:rPr lang="pt-BR" dirty="0"/>
-              <a:t>O QUE SÃO REDES</a:t>
-            </a:r>
-          </a:p>
-        </p:txBody>
-      </p:sp>
-      <p:sp>
-        <p:nvSpPr>
-          <p:cNvPr id="3" name="Espaço Reservado para Conteúdo 2">
-            <a:extLst>
-              <a:ext uri="{FF2B5EF4-FFF2-40B4-BE49-F238E27FC236}">
-                <a16:creationId xmlns:a16="http://schemas.microsoft.com/office/drawing/2014/main" id="{77E062BC-B745-85DD-C631-2AFFE9455B0D}"/>
-              </a:ext>
-            </a:extLst>
-          </p:cNvPr>
-          <p:cNvSpPr>
-            <a:spLocks noGrp="1"/>
-          </p:cNvSpPr>
-          <p:nvPr>
-            <p:ph idx="1"/>
-          </p:nvPr>
-        </p:nvSpPr>
-        <p:spPr>
-          <a:xfrm>
-            <a:off x="1395663" y="2180496"/>
-            <a:ext cx="10215144" cy="3678303"/>
-          </a:xfrm>
-        </p:spPr>
-        <p:txBody>
-          <a:bodyPr>
-            <a:normAutofit/>
-          </a:bodyPr>
-          <a:lstStyle/>
-          <a:p>
-            <a:r>
-              <a:rPr lang="pt-BR" sz="2400" dirty="0"/>
-              <a:t>Uma rede de computadores é a forma de conectarmos equipamentos a fim de que possamos estabelecer uma comunicação entre os mesmos fazendo com que eles troquem dados, informações e serviços. </a:t>
-            </a:r>
-          </a:p>
-        </p:txBody>
-      </p:sp>
-    </p:spTree>
-    <p:extLst>
-      <p:ext uri="{BB962C8B-B14F-4D97-AF65-F5344CB8AC3E}">
-        <p14:creationId xmlns:p14="http://schemas.microsoft.com/office/powerpoint/2010/main" val="2869987137"/>
       </p:ext>
     </p:extLst>
   </p:cSld>

</xml_diff>

<commit_message>
alteração no array e BD
</commit_message>
<xml_diff>
--- a/Redes/REDES DE COMPUTADORES.pptx
+++ b/Redes/REDES DE COMPUTADORES.pptx
@@ -5,10 +5,10 @@
     <p:sldMasterId id="2147483672" r:id="rId1"/>
   </p:sldMasterIdLst>
   <p:notesMasterIdLst>
-    <p:notesMasterId r:id="rId32"/>
+    <p:notesMasterId r:id="rId36"/>
   </p:notesMasterIdLst>
   <p:handoutMasterIdLst>
-    <p:handoutMasterId r:id="rId33"/>
+    <p:handoutMasterId r:id="rId37"/>
   </p:handoutMasterIdLst>
   <p:sldIdLst>
     <p:sldId id="256" r:id="rId2"/>
@@ -40,7 +40,11 @@
     <p:sldId id="288" r:id="rId28"/>
     <p:sldId id="289" r:id="rId29"/>
     <p:sldId id="285" r:id="rId30"/>
-    <p:sldId id="260" r:id="rId31"/>
+    <p:sldId id="292" r:id="rId31"/>
+    <p:sldId id="293" r:id="rId32"/>
+    <p:sldId id="294" r:id="rId33"/>
+    <p:sldId id="295" r:id="rId34"/>
+    <p:sldId id="260" r:id="rId35"/>
   </p:sldIdLst>
   <p:sldSz cx="12192000" cy="6858000"/>
   <p:notesSz cx="6858000" cy="9144000"/>
@@ -150,6 +154,143 @@
 </p:presentation>
 </file>
 
+<file path=ppt/changesInfos/changesInfo1.xml><?xml version="1.0" encoding="utf-8"?>
+<pc:chgInfo xmlns:a="http://schemas.openxmlformats.org/drawingml/2006/main" xmlns:r="http://schemas.openxmlformats.org/officeDocument/2006/relationships" xmlns:ac="http://schemas.microsoft.com/office/drawing/2013/main/command" xmlns:pc="http://schemas.microsoft.com/office/powerpoint/2013/main/command">
+  <pc:docChgLst>
+    <pc:chgData name="Joel Teixeira Cunha" userId="195451ac3a5e8dfd" providerId="LiveId" clId="{9D99295D-09A0-459E-AFDA-61FAD528DEBC}"/>
+    <pc:docChg chg="undo custSel addSld modSld">
+      <pc:chgData name="Joel Teixeira Cunha" userId="195451ac3a5e8dfd" providerId="LiveId" clId="{9D99295D-09A0-459E-AFDA-61FAD528DEBC}" dt="2026-05-18T22:17:41.072" v="1703" actId="1076"/>
+      <pc:docMkLst>
+        <pc:docMk/>
+      </pc:docMkLst>
+      <pc:sldChg chg="modSp mod">
+        <pc:chgData name="Joel Teixeira Cunha" userId="195451ac3a5e8dfd" providerId="LiveId" clId="{9D99295D-09A0-459E-AFDA-61FAD528DEBC}" dt="2026-05-18T22:03:22.235" v="91" actId="20577"/>
+        <pc:sldMkLst>
+          <pc:docMk/>
+          <pc:sldMk cId="2448624542" sldId="285"/>
+        </pc:sldMkLst>
+        <pc:spChg chg="mod">
+          <ac:chgData name="Joel Teixeira Cunha" userId="195451ac3a5e8dfd" providerId="LiveId" clId="{9D99295D-09A0-459E-AFDA-61FAD528DEBC}" dt="2026-05-18T22:03:22.235" v="91" actId="20577"/>
+          <ac:spMkLst>
+            <pc:docMk/>
+            <pc:sldMk cId="2448624542" sldId="285"/>
+            <ac:spMk id="3" creationId="{2F6B353C-1A5B-7BB5-0A90-A4B31FB88685}"/>
+          </ac:spMkLst>
+        </pc:spChg>
+      </pc:sldChg>
+      <pc:sldChg chg="modSp add mod">
+        <pc:chgData name="Joel Teixeira Cunha" userId="195451ac3a5e8dfd" providerId="LiveId" clId="{9D99295D-09A0-459E-AFDA-61FAD528DEBC}" dt="2026-05-18T22:05:24.277" v="266" actId="554"/>
+        <pc:sldMkLst>
+          <pc:docMk/>
+          <pc:sldMk cId="974116489" sldId="292"/>
+        </pc:sldMkLst>
+        <pc:spChg chg="mod">
+          <ac:chgData name="Joel Teixeira Cunha" userId="195451ac3a5e8dfd" providerId="LiveId" clId="{9D99295D-09A0-459E-AFDA-61FAD528DEBC}" dt="2026-05-18T22:03:55.144" v="98" actId="20577"/>
+          <ac:spMkLst>
+            <pc:docMk/>
+            <pc:sldMk cId="974116489" sldId="292"/>
+            <ac:spMk id="2" creationId="{58FAE4EB-9A9A-0E8C-90BA-FF66FE521155}"/>
+          </ac:spMkLst>
+        </pc:spChg>
+        <pc:spChg chg="mod">
+          <ac:chgData name="Joel Teixeira Cunha" userId="195451ac3a5e8dfd" providerId="LiveId" clId="{9D99295D-09A0-459E-AFDA-61FAD528DEBC}" dt="2026-05-18T22:05:24.277" v="266" actId="554"/>
+          <ac:spMkLst>
+            <pc:docMk/>
+            <pc:sldMk cId="974116489" sldId="292"/>
+            <ac:spMk id="3" creationId="{C461B287-8D69-4803-7D99-DF13F17B46F0}"/>
+          </ac:spMkLst>
+        </pc:spChg>
+      </pc:sldChg>
+      <pc:sldChg chg="modSp add mod">
+        <pc:chgData name="Joel Teixeira Cunha" userId="195451ac3a5e8dfd" providerId="LiveId" clId="{9D99295D-09A0-459E-AFDA-61FAD528DEBC}" dt="2026-05-18T22:09:05.343" v="728" actId="20577"/>
+        <pc:sldMkLst>
+          <pc:docMk/>
+          <pc:sldMk cId="3005095367" sldId="293"/>
+        </pc:sldMkLst>
+        <pc:spChg chg="mod">
+          <ac:chgData name="Joel Teixeira Cunha" userId="195451ac3a5e8dfd" providerId="LiveId" clId="{9D99295D-09A0-459E-AFDA-61FAD528DEBC}" dt="2026-05-18T22:05:43.550" v="273" actId="20577"/>
+          <ac:spMkLst>
+            <pc:docMk/>
+            <pc:sldMk cId="3005095367" sldId="293"/>
+            <ac:spMk id="2" creationId="{694774B9-2FB8-E757-C082-1A6174050E85}"/>
+          </ac:spMkLst>
+        </pc:spChg>
+        <pc:spChg chg="mod">
+          <ac:chgData name="Joel Teixeira Cunha" userId="195451ac3a5e8dfd" providerId="LiveId" clId="{9D99295D-09A0-459E-AFDA-61FAD528DEBC}" dt="2026-05-18T22:09:05.343" v="728" actId="20577"/>
+          <ac:spMkLst>
+            <pc:docMk/>
+            <pc:sldMk cId="3005095367" sldId="293"/>
+            <ac:spMk id="3" creationId="{851A2B76-16C4-98C1-5F09-BCA403C9BBBC}"/>
+          </ac:spMkLst>
+        </pc:spChg>
+      </pc:sldChg>
+      <pc:sldChg chg="addSp modSp new mod">
+        <pc:chgData name="Joel Teixeira Cunha" userId="195451ac3a5e8dfd" providerId="LiveId" clId="{9D99295D-09A0-459E-AFDA-61FAD528DEBC}" dt="2026-05-18T22:12:16.062" v="1065"/>
+        <pc:sldMkLst>
+          <pc:docMk/>
+          <pc:sldMk cId="1562692267" sldId="294"/>
+        </pc:sldMkLst>
+        <pc:spChg chg="mod">
+          <ac:chgData name="Joel Teixeira Cunha" userId="195451ac3a5e8dfd" providerId="LiveId" clId="{9D99295D-09A0-459E-AFDA-61FAD528DEBC}" dt="2026-05-18T22:09:35.052" v="755" actId="20577"/>
+          <ac:spMkLst>
+            <pc:docMk/>
+            <pc:sldMk cId="1562692267" sldId="294"/>
+            <ac:spMk id="2" creationId="{D78B2961-D3CA-6F04-431E-CF12565BF917}"/>
+          </ac:spMkLst>
+        </pc:spChg>
+        <pc:spChg chg="mod">
+          <ac:chgData name="Joel Teixeira Cunha" userId="195451ac3a5e8dfd" providerId="LiveId" clId="{9D99295D-09A0-459E-AFDA-61FAD528DEBC}" dt="2026-05-18T22:11:44.767" v="1062" actId="20577"/>
+          <ac:spMkLst>
+            <pc:docMk/>
+            <pc:sldMk cId="1562692267" sldId="294"/>
+            <ac:spMk id="3" creationId="{913FE5D2-5D23-4117-BBB6-08A07C8BCDD8}"/>
+          </ac:spMkLst>
+        </pc:spChg>
+        <pc:picChg chg="add mod">
+          <ac:chgData name="Joel Teixeira Cunha" userId="195451ac3a5e8dfd" providerId="LiveId" clId="{9D99295D-09A0-459E-AFDA-61FAD528DEBC}" dt="2026-05-18T22:12:16.062" v="1065"/>
+          <ac:picMkLst>
+            <pc:docMk/>
+            <pc:sldMk cId="1562692267" sldId="294"/>
+            <ac:picMk id="5" creationId="{80A4EC3A-4951-3982-7D01-F52572EC161D}"/>
+          </ac:picMkLst>
+        </pc:picChg>
+      </pc:sldChg>
+      <pc:sldChg chg="addSp modSp new mod">
+        <pc:chgData name="Joel Teixeira Cunha" userId="195451ac3a5e8dfd" providerId="LiveId" clId="{9D99295D-09A0-459E-AFDA-61FAD528DEBC}" dt="2026-05-18T22:17:41.072" v="1703" actId="1076"/>
+        <pc:sldMkLst>
+          <pc:docMk/>
+          <pc:sldMk cId="3020158856" sldId="295"/>
+        </pc:sldMkLst>
+        <pc:spChg chg="mod">
+          <ac:chgData name="Joel Teixeira Cunha" userId="195451ac3a5e8dfd" providerId="LiveId" clId="{9D99295D-09A0-459E-AFDA-61FAD528DEBC}" dt="2026-05-18T22:12:31.977" v="1090" actId="20577"/>
+          <ac:spMkLst>
+            <pc:docMk/>
+            <pc:sldMk cId="3020158856" sldId="295"/>
+            <ac:spMk id="2" creationId="{B4DE5FC7-2398-B711-7D42-57D885652DDD}"/>
+          </ac:spMkLst>
+        </pc:spChg>
+        <pc:spChg chg="mod">
+          <ac:chgData name="Joel Teixeira Cunha" userId="195451ac3a5e8dfd" providerId="LiveId" clId="{9D99295D-09A0-459E-AFDA-61FAD528DEBC}" dt="2026-05-18T22:17:36.390" v="1702" actId="27636"/>
+          <ac:spMkLst>
+            <pc:docMk/>
+            <pc:sldMk cId="3020158856" sldId="295"/>
+            <ac:spMk id="3" creationId="{281169CA-396E-FD21-629D-8F37D856FF38}"/>
+          </ac:spMkLst>
+        </pc:spChg>
+        <pc:picChg chg="add mod">
+          <ac:chgData name="Joel Teixeira Cunha" userId="195451ac3a5e8dfd" providerId="LiveId" clId="{9D99295D-09A0-459E-AFDA-61FAD528DEBC}" dt="2026-05-18T22:17:41.072" v="1703" actId="1076"/>
+          <ac:picMkLst>
+            <pc:docMk/>
+            <pc:sldMk cId="3020158856" sldId="295"/>
+            <ac:picMk id="5" creationId="{4F68931B-8F48-94FC-507E-33882CBCEEA2}"/>
+          </ac:picMkLst>
+        </pc:picChg>
+      </pc:sldChg>
+    </pc:docChg>
+  </pc:docChgLst>
+</pc:chgInfo>
+</file>
+
 <file path=ppt/handoutMasters/handoutMaster1.xml><?xml version="1.0" encoding="utf-8"?>
 <p:handoutMaster xmlns:a="http://schemas.openxmlformats.org/drawingml/2006/main" xmlns:r="http://schemas.openxmlformats.org/officeDocument/2006/relationships" xmlns:p="http://schemas.openxmlformats.org/presentationml/2006/main">
   <p:cSld>
@@ -246,7 +387,7 @@
             <a:pPr rtl="0"/>
             <a:fld id="{A517C7B7-34F5-4531-9889-28687F60FAC8}" type="datetime1">
               <a:rPr lang="pt-BR" smtClean="0"/>
-              <a:t>06/04/2026</a:t>
+              <a:t>18/05/2026</a:t>
             </a:fld>
             <a:endParaRPr lang="pt-BR" dirty="0"/>
           </a:p>
@@ -427,7 +568,7 @@
             <a:fld id="{40C3EC75-555C-481D-9088-738CE6DDFC83}" type="datetime1">
               <a:rPr lang="pt-BR" smtClean="0"/>
               <a:pPr/>
-              <a:t>06/04/2026</a:t>
+              <a:t>18/05/2026</a:t>
             </a:fld>
             <a:endParaRPr lang="pt-BR" dirty="0"/>
           </a:p>
@@ -850,7 +991,7 @@
             <a:pPr rtl="0"/>
             <a:fld id="{C6B3AB32-59DF-41F1-9618-EDFBF5049629}" type="slidenum">
               <a:rPr lang="pt-BR" smtClean="0"/>
-              <a:t>30</a:t>
+              <a:t>34</a:t>
             </a:fld>
             <a:endParaRPr lang="pt-BR"/>
           </a:p>
@@ -1115,7 +1256,7 @@
             <a:pPr rtl="0"/>
             <a:fld id="{2AF5B136-74F1-42D3-987D-A097EEF8F2FE}" type="datetime1">
               <a:rPr lang="pt-BR" noProof="0" smtClean="0"/>
-              <a:t>06/04/2026</a:t>
+              <a:t>18/05/2026</a:t>
             </a:fld>
             <a:endParaRPr lang="pt-BR" noProof="0"/>
           </a:p>
@@ -1380,7 +1521,7 @@
             <a:pPr rtl="0"/>
             <a:fld id="{0229B074-15EB-43FB-8347-3A734D799093}" type="datetime1">
               <a:rPr lang="pt-BR" noProof="0" smtClean="0"/>
-              <a:t>06/04/2026</a:t>
+              <a:t>18/05/2026</a:t>
             </a:fld>
             <a:endParaRPr lang="pt-BR" noProof="0"/>
           </a:p>
@@ -1618,7 +1759,7 @@
             <a:pPr rtl="0"/>
             <a:fld id="{036303E3-8DE9-4C2D-91EE-6F377AE582A8}" type="datetime1">
               <a:rPr lang="pt-BR" noProof="0" smtClean="0"/>
-              <a:t>06/04/2026</a:t>
+              <a:t>18/05/2026</a:t>
             </a:fld>
             <a:endParaRPr lang="pt-BR" noProof="0"/>
           </a:p>
@@ -1861,7 +2002,7 @@
             <a:pPr rtl="0"/>
             <a:fld id="{B04AF3F4-81C7-4F15-8991-6D0E8D06651A}" type="datetime1">
               <a:rPr lang="pt-BR" noProof="0" smtClean="0"/>
-              <a:t>06/04/2026</a:t>
+              <a:t>18/05/2026</a:t>
             </a:fld>
             <a:endParaRPr lang="pt-BR" noProof="0"/>
           </a:p>
@@ -2172,7 +2313,7 @@
             <a:pPr rtl="0"/>
             <a:fld id="{6E2946E4-8964-43BF-B1D5-4261B83248E5}" type="datetime1">
               <a:rPr lang="pt-BR" noProof="0" smtClean="0"/>
-              <a:t>06/04/2026</a:t>
+              <a:t>18/05/2026</a:t>
             </a:fld>
             <a:endParaRPr lang="pt-BR" noProof="0"/>
           </a:p>
@@ -2476,7 +2617,7 @@
             <a:pPr rtl="0"/>
             <a:fld id="{97C9F420-083C-437A-9265-7F13EB97C6A2}" type="datetime1">
               <a:rPr lang="pt-BR" noProof="0" smtClean="0"/>
-              <a:t>06/04/2026</a:t>
+              <a:t>18/05/2026</a:t>
             </a:fld>
             <a:endParaRPr lang="pt-BR" noProof="0"/>
           </a:p>
@@ -2900,7 +3041,7 @@
             <a:pPr rtl="0"/>
             <a:fld id="{BE07AF20-ED70-4B21-B799-75BB5818AB43}" type="datetime1">
               <a:rPr lang="pt-BR" noProof="0" smtClean="0"/>
-              <a:t>06/04/2026</a:t>
+              <a:t>18/05/2026</a:t>
             </a:fld>
             <a:endParaRPr lang="pt-BR" noProof="0"/>
           </a:p>
@@ -2999,7 +3140,7 @@
             <a:pPr rtl="0"/>
             <a:fld id="{0D33D876-8C34-42FC-BFF7-457557B97BB7}" type="datetime1">
               <a:rPr lang="pt-BR" noProof="0" smtClean="0"/>
-              <a:t>06/04/2026</a:t>
+              <a:t>18/05/2026</a:t>
             </a:fld>
             <a:endParaRPr lang="pt-BR" noProof="0"/>
           </a:p>
@@ -3165,7 +3306,7 @@
             <a:pPr rtl="0"/>
             <a:fld id="{4592437E-206F-4A1C-947F-806A50A40B88}" type="datetime1">
               <a:rPr lang="pt-BR" noProof="0" smtClean="0"/>
-              <a:t>06/04/2026</a:t>
+              <a:t>18/05/2026</a:t>
             </a:fld>
             <a:endParaRPr lang="pt-BR" noProof="0"/>
           </a:p>
@@ -3546,7 +3687,7 @@
             <a:pPr rtl="0"/>
             <a:fld id="{B036DDBC-F1EF-4D09-A533-5995BC167053}" type="datetime1">
               <a:rPr lang="pt-BR" noProof="0" smtClean="0"/>
-              <a:t>06/04/2026</a:t>
+              <a:t>18/05/2026</a:t>
             </a:fld>
             <a:endParaRPr lang="pt-BR" noProof="0"/>
           </a:p>
@@ -3839,7 +3980,7 @@
             <a:pPr rtl="0"/>
             <a:fld id="{DFFDDC01-A1CF-4C3A-BE96-FBC60101324D}" type="datetime1">
               <a:rPr lang="pt-BR" noProof="0" smtClean="0"/>
-              <a:t>06/04/2026</a:t>
+              <a:t>18/05/2026</a:t>
             </a:fld>
             <a:endParaRPr lang="pt-BR" noProof="0"/>
           </a:p>
@@ -4053,7 +4194,7 @@
             <a:pPr rtl="0"/>
             <a:fld id="{52266794-2CD5-4ED3-94F8-8B8DC65FDDE3}" type="datetime1">
               <a:rPr lang="pt-BR" noProof="0" smtClean="0"/>
-              <a:t>06/04/2026</a:t>
+              <a:t>18/05/2026</a:t>
             </a:fld>
             <a:endParaRPr lang="pt-BR" noProof="0"/>
           </a:p>
@@ -8328,7 +8469,13 @@
             </a:r>
             <a:r>
               <a:rPr lang="pt-BR" dirty="0"/>
-              <a:t>. A topologia em </a:t>
+              <a:t>. </a:t>
+            </a:r>
+          </a:p>
+          <a:p>
+            <a:r>
+              <a:rPr lang="pt-BR" dirty="0"/>
+              <a:t>A topologia em </a:t>
             </a:r>
             <a:r>
               <a:rPr lang="pt-BR" u="sng" dirty="0"/>
@@ -8337,6 +8484,12 @@
             <a:r>
               <a:rPr lang="pt-BR" dirty="0"/>
               <a:t>. </a:t>
+            </a:r>
+          </a:p>
+          <a:p>
+            <a:r>
+              <a:rPr lang="pt-BR" dirty="0"/>
+              <a:t>A topologia lógica é o protocolo de comunicação composto por hardwares e softwares</a:t>
             </a:r>
             <a:br>
               <a:rPr lang="pt-BR" dirty="0"/>
@@ -8452,6 +8605,610 @@
 </file>
 
 <file path=ppt/slides/slide30.xml><?xml version="1.0" encoding="utf-8"?>
+<p:sld xmlns:a="http://schemas.openxmlformats.org/drawingml/2006/main" xmlns:r="http://schemas.openxmlformats.org/officeDocument/2006/relationships" xmlns:p="http://schemas.openxmlformats.org/presentationml/2006/main">
+  <p:cSld>
+    <p:spTree>
+      <p:nvGrpSpPr>
+        <p:cNvPr id="1" name="">
+          <a:extLst>
+            <a:ext uri="{FF2B5EF4-FFF2-40B4-BE49-F238E27FC236}">
+              <a16:creationId xmlns:a16="http://schemas.microsoft.com/office/drawing/2014/main" id="{076CE557-9592-6460-02A8-BEE29FB2A6AE}"/>
+            </a:ext>
+          </a:extLst>
+        </p:cNvPr>
+        <p:cNvGrpSpPr/>
+        <p:nvPr/>
+      </p:nvGrpSpPr>
+      <p:grpSpPr>
+        <a:xfrm>
+          <a:off x="0" y="0"/>
+          <a:ext cx="0" cy="0"/>
+          <a:chOff x="0" y="0"/>
+          <a:chExt cx="0" cy="0"/>
+        </a:xfrm>
+      </p:grpSpPr>
+      <p:sp>
+        <p:nvSpPr>
+          <p:cNvPr id="2" name="Título 1">
+            <a:extLst>
+              <a:ext uri="{FF2B5EF4-FFF2-40B4-BE49-F238E27FC236}">
+                <a16:creationId xmlns:a16="http://schemas.microsoft.com/office/drawing/2014/main" id="{58FAE4EB-9A9A-0E8C-90BA-FF66FE521155}"/>
+              </a:ext>
+            </a:extLst>
+          </p:cNvPr>
+          <p:cNvSpPr>
+            <a:spLocks noGrp="1"/>
+          </p:cNvSpPr>
+          <p:nvPr>
+            <p:ph type="title"/>
+          </p:nvPr>
+        </p:nvSpPr>
+        <p:spPr/>
+        <p:txBody>
+          <a:bodyPr/>
+          <a:lstStyle/>
+          <a:p>
+            <a:r>
+              <a:rPr lang="pt-BR" dirty="0"/>
+              <a:t>Topologia lógica</a:t>
+            </a:r>
+          </a:p>
+        </p:txBody>
+      </p:sp>
+      <p:sp>
+        <p:nvSpPr>
+          <p:cNvPr id="3" name="Espaço Reservado para Conteúdo 2">
+            <a:extLst>
+              <a:ext uri="{FF2B5EF4-FFF2-40B4-BE49-F238E27FC236}">
+                <a16:creationId xmlns:a16="http://schemas.microsoft.com/office/drawing/2014/main" id="{C461B287-8D69-4803-7D99-DF13F17B46F0}"/>
+              </a:ext>
+            </a:extLst>
+          </p:cNvPr>
+          <p:cNvSpPr>
+            <a:spLocks noGrp="1"/>
+          </p:cNvSpPr>
+          <p:nvPr>
+            <p:ph idx="1"/>
+          </p:nvPr>
+        </p:nvSpPr>
+        <p:spPr/>
+        <p:txBody>
+          <a:bodyPr>
+            <a:normAutofit/>
+          </a:bodyPr>
+          <a:lstStyle/>
+          <a:p>
+            <a:r>
+              <a:rPr lang="pt-BR" dirty="0"/>
+              <a:t>A topologia lógica é o protocolo de comunicação composto por hardwares e softwares</a:t>
+            </a:r>
+          </a:p>
+          <a:p>
+            <a:r>
+              <a:rPr lang="pt-BR" dirty="0"/>
+              <a:t>Determina qual é a melhor maneira de conectar computadores</a:t>
+            </a:r>
+          </a:p>
+          <a:p>
+            <a:r>
+              <a:rPr lang="pt-BR" dirty="0"/>
+              <a:t>Tipo de dado que será utilizado nas transmissões, modo de transmissão e</a:t>
+            </a:r>
+          </a:p>
+          <a:p>
+            <a:r>
+              <a:rPr lang="pt-BR" dirty="0"/>
+              <a:t>Tipo de placa de rede</a:t>
+            </a:r>
+            <a:br>
+              <a:rPr lang="pt-BR" dirty="0"/>
+            </a:br>
+            <a:endParaRPr lang="pt-BR" dirty="0"/>
+          </a:p>
+        </p:txBody>
+      </p:sp>
+    </p:spTree>
+    <p:extLst>
+      <p:ext uri="{BB962C8B-B14F-4D97-AF65-F5344CB8AC3E}">
+        <p14:creationId xmlns:p14="http://schemas.microsoft.com/office/powerpoint/2010/main" val="974116489"/>
+      </p:ext>
+    </p:extLst>
+  </p:cSld>
+  <p:clrMapOvr>
+    <a:masterClrMapping/>
+  </p:clrMapOvr>
+</p:sld>
+</file>
+
+<file path=ppt/slides/slide31.xml><?xml version="1.0" encoding="utf-8"?>
+<p:sld xmlns:a="http://schemas.openxmlformats.org/drawingml/2006/main" xmlns:r="http://schemas.openxmlformats.org/officeDocument/2006/relationships" xmlns:p="http://schemas.openxmlformats.org/presentationml/2006/main">
+  <p:cSld>
+    <p:spTree>
+      <p:nvGrpSpPr>
+        <p:cNvPr id="1" name="">
+          <a:extLst>
+            <a:ext uri="{FF2B5EF4-FFF2-40B4-BE49-F238E27FC236}">
+              <a16:creationId xmlns:a16="http://schemas.microsoft.com/office/drawing/2014/main" id="{F0D9D2C4-8FE6-1A10-7974-BB0128865B08}"/>
+            </a:ext>
+          </a:extLst>
+        </p:cNvPr>
+        <p:cNvGrpSpPr/>
+        <p:nvPr/>
+      </p:nvGrpSpPr>
+      <p:grpSpPr>
+        <a:xfrm>
+          <a:off x="0" y="0"/>
+          <a:ext cx="0" cy="0"/>
+          <a:chOff x="0" y="0"/>
+          <a:chExt cx="0" cy="0"/>
+        </a:xfrm>
+      </p:grpSpPr>
+      <p:sp>
+        <p:nvSpPr>
+          <p:cNvPr id="2" name="Título 1">
+            <a:extLst>
+              <a:ext uri="{FF2B5EF4-FFF2-40B4-BE49-F238E27FC236}">
+                <a16:creationId xmlns:a16="http://schemas.microsoft.com/office/drawing/2014/main" id="{694774B9-2FB8-E757-C082-1A6174050E85}"/>
+              </a:ext>
+            </a:extLst>
+          </p:cNvPr>
+          <p:cNvSpPr>
+            <a:spLocks noGrp="1"/>
+          </p:cNvSpPr>
+          <p:nvPr>
+            <p:ph type="title"/>
+          </p:nvPr>
+        </p:nvSpPr>
+        <p:spPr/>
+        <p:txBody>
+          <a:bodyPr/>
+          <a:lstStyle/>
+          <a:p>
+            <a:r>
+              <a:rPr lang="pt-BR" dirty="0"/>
+              <a:t>Topologia física</a:t>
+            </a:r>
+          </a:p>
+        </p:txBody>
+      </p:sp>
+      <p:sp>
+        <p:nvSpPr>
+          <p:cNvPr id="3" name="Espaço Reservado para Conteúdo 2">
+            <a:extLst>
+              <a:ext uri="{FF2B5EF4-FFF2-40B4-BE49-F238E27FC236}">
+                <a16:creationId xmlns:a16="http://schemas.microsoft.com/office/drawing/2014/main" id="{851A2B76-16C4-98C1-5F09-BCA403C9BBBC}"/>
+              </a:ext>
+            </a:extLst>
+          </p:cNvPr>
+          <p:cNvSpPr>
+            <a:spLocks noGrp="1"/>
+          </p:cNvSpPr>
+          <p:nvPr>
+            <p:ph idx="1"/>
+          </p:nvPr>
+        </p:nvSpPr>
+        <p:spPr/>
+        <p:txBody>
+          <a:bodyPr>
+            <a:normAutofit/>
+          </a:bodyPr>
+          <a:lstStyle/>
+          <a:p>
+            <a:r>
+              <a:rPr lang="pt-BR" dirty="0"/>
+              <a:t>Forma de distribuição dos cabos e dispositivos na rede</a:t>
+            </a:r>
+          </a:p>
+          <a:p>
+            <a:r>
+              <a:rPr lang="pt-BR" dirty="0"/>
+              <a:t>Influencia em como será o fluxo da informação</a:t>
+            </a:r>
+          </a:p>
+          <a:p>
+            <a:r>
+              <a:rPr lang="pt-BR" dirty="0"/>
+              <a:t>Determina os caminhos físicos</a:t>
+            </a:r>
+          </a:p>
+          <a:p>
+            <a:r>
+              <a:rPr lang="pt-BR" dirty="0"/>
+              <a:t>Busca atender às necessidades específicas de cada local levando em consideração os seguintes critérios</a:t>
+            </a:r>
+          </a:p>
+          <a:p>
+            <a:pPr lvl="1"/>
+            <a:r>
+              <a:rPr lang="pt-BR" dirty="0"/>
+              <a:t>Confiabilidade: garante aos usuários o funcionamento da rede de forma confiável;</a:t>
+            </a:r>
+          </a:p>
+          <a:p>
+            <a:pPr lvl="1"/>
+            <a:r>
+              <a:rPr lang="pt-BR" dirty="0"/>
+              <a:t>Capacidade de desempenho: a rede deve ter um desempenho aceitável</a:t>
+            </a:r>
+          </a:p>
+          <a:p>
+            <a:pPr lvl="1"/>
+            <a:r>
+              <a:rPr lang="pt-BR" dirty="0"/>
+              <a:t>Custo operacional e possibilidades de expansão: planejamento anterior</a:t>
+            </a:r>
+          </a:p>
+        </p:txBody>
+      </p:sp>
+    </p:spTree>
+    <p:extLst>
+      <p:ext uri="{BB962C8B-B14F-4D97-AF65-F5344CB8AC3E}">
+        <p14:creationId xmlns:p14="http://schemas.microsoft.com/office/powerpoint/2010/main" val="3005095367"/>
+      </p:ext>
+    </p:extLst>
+  </p:cSld>
+  <p:clrMapOvr>
+    <a:masterClrMapping/>
+  </p:clrMapOvr>
+</p:sld>
+</file>
+
+<file path=ppt/slides/slide32.xml><?xml version="1.0" encoding="utf-8"?>
+<p:sld xmlns:a="http://schemas.openxmlformats.org/drawingml/2006/main" xmlns:r="http://schemas.openxmlformats.org/officeDocument/2006/relationships" xmlns:p="http://schemas.openxmlformats.org/presentationml/2006/main">
+  <p:cSld>
+    <p:spTree>
+      <p:nvGrpSpPr>
+        <p:cNvPr id="1" name=""/>
+        <p:cNvGrpSpPr/>
+        <p:nvPr/>
+      </p:nvGrpSpPr>
+      <p:grpSpPr>
+        <a:xfrm>
+          <a:off x="0" y="0"/>
+          <a:ext cx="0" cy="0"/>
+          <a:chOff x="0" y="0"/>
+          <a:chExt cx="0" cy="0"/>
+        </a:xfrm>
+      </p:grpSpPr>
+      <p:sp>
+        <p:nvSpPr>
+          <p:cNvPr id="2" name="Título 1">
+            <a:extLst>
+              <a:ext uri="{FF2B5EF4-FFF2-40B4-BE49-F238E27FC236}">
+                <a16:creationId xmlns:a16="http://schemas.microsoft.com/office/drawing/2014/main" id="{D78B2961-D3CA-6F04-431E-CF12565BF917}"/>
+              </a:ext>
+            </a:extLst>
+          </p:cNvPr>
+          <p:cNvSpPr>
+            <a:spLocks noGrp="1"/>
+          </p:cNvSpPr>
+          <p:nvPr>
+            <p:ph type="title"/>
+          </p:nvPr>
+        </p:nvSpPr>
+        <p:spPr/>
+        <p:txBody>
+          <a:bodyPr/>
+          <a:lstStyle/>
+          <a:p>
+            <a:r>
+              <a:rPr lang="pt-BR" dirty="0"/>
+              <a:t>Topologia ponto-a-ponto</a:t>
+            </a:r>
+          </a:p>
+        </p:txBody>
+      </p:sp>
+      <p:sp>
+        <p:nvSpPr>
+          <p:cNvPr id="3" name="Espaço Reservado para Conteúdo 2">
+            <a:extLst>
+              <a:ext uri="{FF2B5EF4-FFF2-40B4-BE49-F238E27FC236}">
+                <a16:creationId xmlns:a16="http://schemas.microsoft.com/office/drawing/2014/main" id="{913FE5D2-5D23-4117-BBB6-08A07C8BCDD8}"/>
+              </a:ext>
+            </a:extLst>
+          </p:cNvPr>
+          <p:cNvSpPr>
+            <a:spLocks noGrp="1"/>
+          </p:cNvSpPr>
+          <p:nvPr>
+            <p:ph idx="1"/>
+          </p:nvPr>
+        </p:nvSpPr>
+        <p:spPr/>
+        <p:txBody>
+          <a:bodyPr/>
+          <a:lstStyle/>
+          <a:p>
+            <a:r>
+              <a:rPr lang="pt-BR" dirty="0"/>
+              <a:t>Forma de topologia mais simples.</a:t>
+            </a:r>
+          </a:p>
+          <a:p>
+            <a:r>
+              <a:rPr lang="pt-BR" dirty="0"/>
+              <a:t>Conexão entre dois computadores</a:t>
+            </a:r>
+          </a:p>
+          <a:p>
+            <a:r>
+              <a:rPr lang="pt-BR" dirty="0"/>
+              <a:t>Características:</a:t>
+            </a:r>
+          </a:p>
+          <a:p>
+            <a:pPr lvl="1"/>
+            <a:r>
+              <a:rPr lang="pt-BR" dirty="0"/>
+              <a:t>Cada uma pode ter características próprias que independem de outras conexões na mesma rede;</a:t>
+            </a:r>
+          </a:p>
+          <a:p>
+            <a:pPr lvl="1"/>
+            <a:r>
+              <a:rPr lang="pt-BR" dirty="0"/>
+              <a:t>Facilidade para implantar medidas de segurança e privacidade;</a:t>
+            </a:r>
+          </a:p>
+          <a:p>
+            <a:pPr lvl="1"/>
+            <a:r>
+              <a:rPr lang="pt-BR" dirty="0"/>
+              <a:t>Não existe necessidade de dar nomes (endereçar) aos participantes</a:t>
+            </a:r>
+          </a:p>
+        </p:txBody>
+      </p:sp>
+      <p:pic>
+        <p:nvPicPr>
+          <p:cNvPr id="5" name="Imagem 4">
+            <a:extLst>
+              <a:ext uri="{FF2B5EF4-FFF2-40B4-BE49-F238E27FC236}">
+                <a16:creationId xmlns:a16="http://schemas.microsoft.com/office/drawing/2014/main" id="{80A4EC3A-4951-3982-7D01-F52572EC161D}"/>
+              </a:ext>
+            </a:extLst>
+          </p:cNvPr>
+          <p:cNvPicPr>
+            <a:picLocks noChangeAspect="1"/>
+          </p:cNvPicPr>
+          <p:nvPr/>
+        </p:nvPicPr>
+        <p:blipFill>
+          <a:blip r:embed="rId2">
+            <a:clrChange>
+              <a:clrFrom>
+                <a:srgbClr val="FFFFFF"/>
+              </a:clrFrom>
+              <a:clrTo>
+                <a:srgbClr val="FFFFFF">
+                  <a:alpha val="0"/>
+                </a:srgbClr>
+              </a:clrTo>
+            </a:clrChange>
+          </a:blip>
+          <a:stretch>
+            <a:fillRect/>
+          </a:stretch>
+        </p:blipFill>
+        <p:spPr>
+          <a:xfrm>
+            <a:off x="5733859" y="2180496"/>
+            <a:ext cx="5534025" cy="1600200"/>
+          </a:xfrm>
+          <a:prstGeom prst="rect">
+            <a:avLst/>
+          </a:prstGeom>
+        </p:spPr>
+      </p:pic>
+    </p:spTree>
+    <p:extLst>
+      <p:ext uri="{BB962C8B-B14F-4D97-AF65-F5344CB8AC3E}">
+        <p14:creationId xmlns:p14="http://schemas.microsoft.com/office/powerpoint/2010/main" val="1562692267"/>
+      </p:ext>
+    </p:extLst>
+  </p:cSld>
+  <p:clrMapOvr>
+    <a:masterClrMapping/>
+  </p:clrMapOvr>
+</p:sld>
+</file>
+
+<file path=ppt/slides/slide33.xml><?xml version="1.0" encoding="utf-8"?>
+<p:sld xmlns:a="http://schemas.openxmlformats.org/drawingml/2006/main" xmlns:r="http://schemas.openxmlformats.org/officeDocument/2006/relationships" xmlns:p="http://schemas.openxmlformats.org/presentationml/2006/main">
+  <p:cSld>
+    <p:spTree>
+      <p:nvGrpSpPr>
+        <p:cNvPr id="1" name=""/>
+        <p:cNvGrpSpPr/>
+        <p:nvPr/>
+      </p:nvGrpSpPr>
+      <p:grpSpPr>
+        <a:xfrm>
+          <a:off x="0" y="0"/>
+          <a:ext cx="0" cy="0"/>
+          <a:chOff x="0" y="0"/>
+          <a:chExt cx="0" cy="0"/>
+        </a:xfrm>
+      </p:grpSpPr>
+      <p:sp>
+        <p:nvSpPr>
+          <p:cNvPr id="2" name="Título 1">
+            <a:extLst>
+              <a:ext uri="{FF2B5EF4-FFF2-40B4-BE49-F238E27FC236}">
+                <a16:creationId xmlns:a16="http://schemas.microsoft.com/office/drawing/2014/main" id="{B4DE5FC7-2398-B711-7D42-57D885652DDD}"/>
+              </a:ext>
+            </a:extLst>
+          </p:cNvPr>
+          <p:cNvSpPr>
+            <a:spLocks noGrp="1"/>
+          </p:cNvSpPr>
+          <p:nvPr>
+            <p:ph type="title"/>
+          </p:nvPr>
+        </p:nvSpPr>
+        <p:spPr/>
+        <p:txBody>
+          <a:bodyPr/>
+          <a:lstStyle/>
+          <a:p>
+            <a:r>
+              <a:rPr lang="pt-BR" dirty="0"/>
+              <a:t>Topologia em barramento</a:t>
+            </a:r>
+          </a:p>
+        </p:txBody>
+      </p:sp>
+      <p:sp>
+        <p:nvSpPr>
+          <p:cNvPr id="3" name="Espaço Reservado para Conteúdo 2">
+            <a:extLst>
+              <a:ext uri="{FF2B5EF4-FFF2-40B4-BE49-F238E27FC236}">
+                <a16:creationId xmlns:a16="http://schemas.microsoft.com/office/drawing/2014/main" id="{281169CA-396E-FD21-629D-8F37D856FF38}"/>
+              </a:ext>
+            </a:extLst>
+          </p:cNvPr>
+          <p:cNvSpPr>
+            <a:spLocks noGrp="1"/>
+          </p:cNvSpPr>
+          <p:nvPr>
+            <p:ph idx="1"/>
+          </p:nvPr>
+        </p:nvSpPr>
+        <p:spPr>
+          <a:xfrm>
+            <a:off x="581193" y="2180496"/>
+            <a:ext cx="7328368" cy="3678303"/>
+          </a:xfrm>
+        </p:spPr>
+        <p:txBody>
+          <a:bodyPr>
+            <a:normAutofit fontScale="92500" lnSpcReduction="20000"/>
+          </a:bodyPr>
+          <a:lstStyle/>
+          <a:p>
+            <a:r>
+              <a:rPr lang="pt-BR" dirty="0"/>
+              <a:t>Todos os computadores são conectados diretamente em um mesmo cabo;</a:t>
+            </a:r>
+          </a:p>
+          <a:p>
+            <a:r>
+              <a:rPr lang="pt-BR" dirty="0"/>
+              <a:t>Quando uma mensagem é enviada pela rede, ela passa por todos os computadores conectados ao barramento</a:t>
+            </a:r>
+          </a:p>
+          <a:p>
+            <a:r>
+              <a:rPr lang="pt-BR" dirty="0"/>
+              <a:t>Características:</a:t>
+            </a:r>
+          </a:p>
+          <a:p>
+            <a:pPr lvl="1"/>
+            <a:r>
+              <a:rPr lang="pt-BR" dirty="0"/>
+              <a:t>Facilidade para o acréscimo de novos computadores à rede;</a:t>
+            </a:r>
+          </a:p>
+          <a:p>
+            <a:pPr lvl="1"/>
+            <a:r>
+              <a:rPr lang="pt-BR" dirty="0"/>
+              <a:t>Fluxo da informação descentralizado;</a:t>
+            </a:r>
+          </a:p>
+          <a:p>
+            <a:pPr lvl="1"/>
+            <a:r>
+              <a:rPr lang="pt-BR" dirty="0"/>
+              <a:t>Um problema em um computador pode causar uma queda em toda a rede;</a:t>
+            </a:r>
+          </a:p>
+          <a:p>
+            <a:pPr lvl="1"/>
+            <a:r>
+              <a:rPr lang="pt-BR" dirty="0"/>
+              <a:t>A extensão da rede é limitada pelo tamanho do cabo;</a:t>
+            </a:r>
+          </a:p>
+          <a:p>
+            <a:pPr lvl="1"/>
+            <a:r>
+              <a:rPr lang="pt-BR" dirty="0"/>
+              <a:t>Exige mecanismos especiais de controle de acesso;</a:t>
+            </a:r>
+          </a:p>
+          <a:p>
+            <a:pPr lvl="1"/>
+            <a:r>
+              <a:rPr lang="pt-BR" dirty="0"/>
+              <a:t>Necessidade de haver endereço para cada par (nomes) permitindo a comunicação par-a-par</a:t>
+            </a:r>
+          </a:p>
+          <a:p>
+            <a:pPr lvl="1"/>
+            <a:r>
+              <a:rPr lang="pt-BR" dirty="0"/>
+              <a:t>Simplicidade, baixo custo, fácil instalação e expansão</a:t>
+            </a:r>
+          </a:p>
+        </p:txBody>
+      </p:sp>
+      <p:pic>
+        <p:nvPicPr>
+          <p:cNvPr id="5" name="Imagem 4">
+            <a:extLst>
+              <a:ext uri="{FF2B5EF4-FFF2-40B4-BE49-F238E27FC236}">
+                <a16:creationId xmlns:a16="http://schemas.microsoft.com/office/drawing/2014/main" id="{4F68931B-8F48-94FC-507E-33882CBCEEA2}"/>
+              </a:ext>
+            </a:extLst>
+          </p:cNvPr>
+          <p:cNvPicPr>
+            <a:picLocks noChangeAspect="1"/>
+          </p:cNvPicPr>
+          <p:nvPr/>
+        </p:nvPicPr>
+        <p:blipFill>
+          <a:blip r:embed="rId2">
+            <a:clrChange>
+              <a:clrFrom>
+                <a:srgbClr val="FFFFFF"/>
+              </a:clrFrom>
+              <a:clrTo>
+                <a:srgbClr val="FFFFFF">
+                  <a:alpha val="0"/>
+                </a:srgbClr>
+              </a:clrTo>
+            </a:clrChange>
+          </a:blip>
+          <a:stretch>
+            <a:fillRect/>
+          </a:stretch>
+        </p:blipFill>
+        <p:spPr>
+          <a:xfrm>
+            <a:off x="6935606" y="1911096"/>
+            <a:ext cx="5364598" cy="2289620"/>
+          </a:xfrm>
+          <a:prstGeom prst="rect">
+            <a:avLst/>
+          </a:prstGeom>
+        </p:spPr>
+      </p:pic>
+    </p:spTree>
+    <p:extLst>
+      <p:ext uri="{BB962C8B-B14F-4D97-AF65-F5344CB8AC3E}">
+        <p14:creationId xmlns:p14="http://schemas.microsoft.com/office/powerpoint/2010/main" val="3020158856"/>
+      </p:ext>
+    </p:extLst>
+  </p:cSld>
+  <p:clrMapOvr>
+    <a:masterClrMapping/>
+  </p:clrMapOvr>
+</p:sld>
+</file>
+
+<file path=ppt/slides/slide34.xml><?xml version="1.0" encoding="utf-8"?>
 <p:sld xmlns:a="http://schemas.openxmlformats.org/drawingml/2006/main" xmlns:r="http://schemas.openxmlformats.org/officeDocument/2006/relationships" xmlns:p="http://schemas.openxmlformats.org/presentationml/2006/main">
   <p:cSld>
     <p:bg>

</xml_diff>